<commit_message>
docs(enablement): split dense glossary slide; complete daily-loop bullets
</commit_message>
<xml_diff>
--- a/docs/gtm/enablement/deck/Directing-Claude.pptx
+++ b/docs/gtm/enablement/deck/Directing-Claude.pptx
@@ -38,6 +38,7 @@
     <p:sldId id="286" r:id="rId38"/>
     <p:sldId id="287" r:id="rId39"/>
     <p:sldId id="288" r:id="rId40"/>
+    <p:sldId id="289" r:id="rId41"/>
   </p:sldIdLst>
   <p:sldSz cx="12191695" cy="6858000" type="screen4x3"/>
   <p:notesSz cx="6858000" cy="9144000"/>
@@ -624,27 +625,17 @@
           <a:lstStyle/>
           <a:p>
             <a:r>
-              <a:t>~15 minutes. Show the Contoso example pair first so they see the shape (short rulebook, fuller</a:t>
-            </a:r>
-          </a:p>
-          <a:p>
-            <a:r>
-              <a:t>context doc it points to) before asking Claude to draft their own. Step 3 — reading before</a:t>
-            </a:r>
-          </a:p>
-          <a:p>
-            <a:r>
-              <a:t>accepting — is the "check what it did" half of the spine, not a formality. If Claude's draft</a:t>
-            </a:r>
-          </a:p>
-          <a:p>
-            <a:r>
-              <a:t>reads generic, the fix is almost always that the new `CLAUDE.md` doesn't actually point at the</a:t>
-            </a:r>
-          </a:p>
-          <a:p>
-            <a:r>
-              <a:t>new `PROJECT_CONTEXT.md` yet.</a:t>
+              <a:t>Don't move on until every attendee has actually done this themselves, not just watched you do</a:t>
+            </a:r>
+          </a:p>
+          <a:p>
+            <a:r>
+              <a:t>it. If `claude` isn't recognized, closing and reopening the terminal once usually fixes it —</a:t>
+            </a:r>
+          </a:p>
+          <a:p>
+            <a:r>
+              <a:t>that refreshes the list of commands it knows about.</a:t>
             </a:r>
           </a:p>
         </p:txBody>
@@ -714,17 +705,27 @@
           <a:lstStyle/>
           <a:p>
             <a:r>
-              <a:t>This is the single clearest sign the rulebook is wired up correctly. If the answer describes</a:t>
-            </a:r>
-          </a:p>
-          <a:p>
-            <a:r>
-              <a:t>Contoso instead of their own project, the files were probably saved inside `examples/` instead</a:t>
-            </a:r>
-          </a:p>
-          <a:p>
-            <a:r>
-              <a:t>of at the project root — check that before anything else.</a:t>
+              <a:t>~15 minutes. Show the Contoso example pair first so they see the shape (short rulebook, fuller</a:t>
+            </a:r>
+          </a:p>
+          <a:p>
+            <a:r>
+              <a:t>context doc it points to) before asking Claude to draft their own. Step 3 — reading before</a:t>
+            </a:r>
+          </a:p>
+          <a:p>
+            <a:r>
+              <a:t>accepting — is the "check what it did" half of the spine, not a formality. If Claude's draft</a:t>
+            </a:r>
+          </a:p>
+          <a:p>
+            <a:r>
+              <a:t>reads generic, the fix is almost always that the new `CLAUDE.md` doesn't actually point at the</a:t>
+            </a:r>
+          </a:p>
+          <a:p>
+            <a:r>
+              <a:t>new `PROJECT_CONTEXT.md` yet.</a:t>
             </a:r>
           </a:p>
         </p:txBody>
@@ -794,22 +795,17 @@
           <a:lstStyle/>
           <a:p>
             <a:r>
-              <a:t>~10 minutes. A good first fact to seed: who the backup owner is for this project. That does</a:t>
-            </a:r>
-          </a:p>
-          <a:p>
-            <a:r>
-              <a:t>double duty — it's a real, useful memory, and it previews the continuity story that closes out</a:t>
-            </a:r>
-          </a:p>
-          <a:p>
-            <a:r>
-              <a:t>the whole deck. Memory lives per-project on their own machine; a different project folder looks</a:t>
-            </a:r>
-          </a:p>
-          <a:p>
-            <a:r>
-              <a:t>like a different project to Claude, which is why the checkpoint insists on the same folder.</a:t>
+              <a:t>This is the single clearest sign the rulebook is wired up correctly. If the answer describes</a:t>
+            </a:r>
+          </a:p>
+          <a:p>
+            <a:r>
+              <a:t>Contoso instead of their own project, the files were probably saved inside `examples/` instead</a:t>
+            </a:r>
+          </a:p>
+          <a:p>
+            <a:r>
+              <a:t>of at the project root — check that before anything else.</a:t>
             </a:r>
           </a:p>
         </p:txBody>
@@ -879,17 +875,22 @@
           <a:lstStyle/>
           <a:p>
             <a:r>
-              <a:t>The word "fresh" matters here — make everyone actually close and reopen, not just scroll up in</a:t>
-            </a:r>
-          </a:p>
-          <a:p>
-            <a:r>
-              <a:t>the same conversation. That's the whole point: memory survives closing the laptop and coming</a:t>
-            </a:r>
-          </a:p>
-          <a:p>
-            <a:r>
-              <a:t>back tomorrow, not just survives within one chat.</a:t>
+              <a:t>~10 minutes. A good first fact to seed: who the backup owner is for this project. That does</a:t>
+            </a:r>
+          </a:p>
+          <a:p>
+            <a:r>
+              <a:t>double duty — it's a real, useful memory, and it previews the continuity story that closes out</a:t>
+            </a:r>
+          </a:p>
+          <a:p>
+            <a:r>
+              <a:t>the whole deck. Memory lives per-project on their own machine; a different project folder looks</a:t>
+            </a:r>
+          </a:p>
+          <a:p>
+            <a:r>
+              <a:t>like a different project to Claude, which is why the checkpoint insists on the same folder.</a:t>
             </a:r>
           </a:p>
         </p:txBody>
@@ -959,17 +960,17 @@
           <a:lstStyle/>
           <a:p>
             <a:r>
-              <a:t>Quick recap before a break or before moving straight into Session 2. Reinforce that nothing</a:t>
-            </a:r>
-          </a:p>
-          <a:p>
-            <a:r>
-              <a:t>scary happened today — they installed a tool, told it about their project, and told it one</a:t>
-            </a:r>
-          </a:p>
-          <a:p>
-            <a:r>
-              <a:t>fact to remember. Session 2 is where it starts producing real, saved, reviewable work.</a:t>
+              <a:t>The word "fresh" matters here — make everyone actually close and reopen, not just scroll up in</a:t>
+            </a:r>
+          </a:p>
+          <a:p>
+            <a:r>
+              <a:t>the same conversation. That's the whole point: memory survives closing the laptop and coming</a:t>
+            </a:r>
+          </a:p>
+          <a:p>
+            <a:r>
+              <a:t>back tomorrow, not just survives within one chat.</a:t>
             </a:r>
           </a:p>
         </p:txBody>
@@ -1039,22 +1040,17 @@
           <a:lstStyle/>
           <a:p>
             <a:r>
-              <a:t>Section transition. Session 2 is Modules 4 through 7, roughly 60 to 75 minutes, with Module 5</a:t>
-            </a:r>
-          </a:p>
-          <a:p>
-            <a:r>
-              <a:t>(sandbox + PR) as the long pole — don't rush that checkpoint, it's this session's proof point.</a:t>
-            </a:r>
-          </a:p>
-          <a:p>
-            <a:r>
-              <a:t>Picks up from Session 1's project-aware Claude and ends with a real Azure DevOps PR, a skill</a:t>
-            </a:r>
-          </a:p>
-          <a:p>
-            <a:r>
-              <a:t>run, and a live tool connection.</a:t>
+              <a:t>Quick recap before a break or before moving straight into Session 2. Reinforce that nothing</a:t>
+            </a:r>
+          </a:p>
+          <a:p>
+            <a:r>
+              <a:t>scary happened today — they installed a tool, told it about their project, and told it one</a:t>
+            </a:r>
+          </a:p>
+          <a:p>
+            <a:r>
+              <a:t>fact to remember. Session 2 is where it starts producing real, saved, reviewable work.</a:t>
             </a:r>
           </a:p>
         </p:txBody>
@@ -1124,22 +1120,22 @@
           <a:lstStyle/>
           <a:p>
             <a:r>
-              <a:t>~15 minutes. This is the loop they'll repeat for every piece of work, big or small, from here</a:t>
-            </a:r>
-          </a:p>
-          <a:p>
-            <a:r>
-              <a:t>on. The single most important habit to drill in this module: if Claude jumps straight to code,</a:t>
-            </a:r>
-          </a:p>
-          <a:p>
-            <a:r>
-              <a:t>stop it and say plainly, "don't write code yet — write the plan first." Stop the room here,</a:t>
-            </a:r>
-          </a:p>
-          <a:p>
-            <a:r>
-              <a:t>before any code gets written, and move to the Contoso walkthrough on the next slide.</a:t>
+              <a:t>Section transition. Session 2 is Modules 4 through 7, roughly 60 to 75 minutes, with Module 5</a:t>
+            </a:r>
+          </a:p>
+          <a:p>
+            <a:r>
+              <a:t>(sandbox + PR) as the long pole — don't rush that checkpoint, it's this session's proof point.</a:t>
+            </a:r>
+          </a:p>
+          <a:p>
+            <a:r>
+              <a:t>Picks up from Session 1's project-aware Claude and ends with a real Azure DevOps PR, a skill</a:t>
+            </a:r>
+          </a:p>
+          <a:p>
+            <a:r>
+              <a:t>run, and a live tool connection.</a:t>
             </a:r>
           </a:p>
         </p:txBody>
@@ -1209,27 +1205,22 @@
           <a:lstStyle/>
           <a:p>
             <a:r>
-              <a:t>This is Module 4's hands-on checkpoint. "Done-criteria" is a term worth pausing on: it just</a:t>
-            </a:r>
-          </a:p>
-          <a:p>
-            <a:r>
-              <a:t>means the exact check that proves the work worked, which Claude runs and reports back in plain</a:t>
-            </a:r>
-          </a:p>
-          <a:p>
-            <a:r>
-              <a:t>English. The finished reference plan (`sample-plan.md`) is there for them to compare their own</a:t>
-            </a:r>
-          </a:p>
-          <a:p>
-            <a:r>
-              <a:t>plan against — it won't read word-for-word the same, and that's fine, it should have the same</a:t>
-            </a:r>
-          </a:p>
-          <a:p>
-            <a:r>
-              <a:t>shape: a goal, a short list of steps, and a Done-criteria section.</a:t>
+              <a:t>~15 minutes. This is the loop they'll repeat for every piece of work, big or small, from here</a:t>
+            </a:r>
+          </a:p>
+          <a:p>
+            <a:r>
+              <a:t>on. The single most important habit to drill in this module: if Claude jumps straight to code,</a:t>
+            </a:r>
+          </a:p>
+          <a:p>
+            <a:r>
+              <a:t>stop it and say plainly, "don't write code yet — write the plan first." Stop the room here,</a:t>
+            </a:r>
+          </a:p>
+          <a:p>
+            <a:r>
+              <a:t>before any code gets written, and move to the Contoso walkthrough on the next slide.</a:t>
             </a:r>
           </a:p>
         </p:txBody>
@@ -1299,27 +1290,27 @@
           <a:lstStyle/>
           <a:p>
             <a:r>
-              <a:t>~25 minutes, the longest module today. A worktree is a separate, complete copy of the project</a:t>
-            </a:r>
-          </a:p>
-          <a:p>
-            <a:r>
-              <a:t>on its own branch — nothing done inside it can break the version everyone else relies on until</a:t>
-            </a:r>
-          </a:p>
-          <a:p>
-            <a:r>
-              <a:t>it's deliberately shared for review. They don't need to type any `git worktree` commands</a:t>
-            </a:r>
-          </a:p>
-          <a:p>
-            <a:r>
-              <a:t>themselves; asking Claude in plain English is enough. Remind them `&lt;branch&gt;` in the PR command</a:t>
-            </a:r>
-          </a:p>
-          <a:p>
-            <a:r>
-              <a:t>is whatever branch their sandbox is on — ask Claude "what branch am I on?" if unsure.</a:t>
+              <a:t>This is Module 4's hands-on checkpoint. "Done-criteria" is a term worth pausing on: it just</a:t>
+            </a:r>
+          </a:p>
+          <a:p>
+            <a:r>
+              <a:t>means the exact check that proves the work worked, which Claude runs and reports back in plain</a:t>
+            </a:r>
+          </a:p>
+          <a:p>
+            <a:r>
+              <a:t>English. The finished reference plan (`sample-plan.md`) is there for them to compare their own</a:t>
+            </a:r>
+          </a:p>
+          <a:p>
+            <a:r>
+              <a:t>plan against — it won't read word-for-word the same, and that's fine, it should have the same</a:t>
+            </a:r>
+          </a:p>
+          <a:p>
+            <a:r>
+              <a:t>shape: a goal, a short list of steps, and a Done-criteria section.</a:t>
             </a:r>
           </a:p>
         </p:txBody>
@@ -1389,17 +1380,27 @@
           <a:lstStyle/>
           <a:p>
             <a:r>
-              <a:t>This is today's proof point — don't rush past it. If the PR command fails, it's almost always</a:t>
-            </a:r>
-          </a:p>
-          <a:p>
-            <a:r>
-              <a:t>a sign-in issue (`az login` once per machine) or the commit didn't actually happen inside the</a:t>
-            </a:r>
-          </a:p>
-          <a:p>
-            <a:r>
-              <a:t>sandbox branch before opening the PR — ask Claude to check both in plain English.</a:t>
+              <a:t>~25 minutes, the longest module today. A worktree is a separate, complete copy of the project</a:t>
+            </a:r>
+          </a:p>
+          <a:p>
+            <a:r>
+              <a:t>on its own branch — nothing done inside it can break the version everyone else relies on until</a:t>
+            </a:r>
+          </a:p>
+          <a:p>
+            <a:r>
+              <a:t>it's deliberately shared for review. They don't need to type any `git worktree` commands</a:t>
+            </a:r>
+          </a:p>
+          <a:p>
+            <a:r>
+              <a:t>themselves; asking Claude in plain English is enough. Remind them `&lt;branch&gt;` in the PR command</a:t>
+            </a:r>
+          </a:p>
+          <a:p>
+            <a:r>
+              <a:t>is whatever branch their sandbox is on — ask Claude "what branch am I on?" if unsure.</a:t>
             </a:r>
           </a:p>
         </p:txBody>
@@ -1559,27 +1560,17 @@
           <a:lstStyle/>
           <a:p>
             <a:r>
-              <a:t>~15 minutes. Show the skill file itself first — name, plain description, a short numbered</a:t>
-            </a:r>
-          </a:p>
-          <a:p>
-            <a:r>
-              <a:t>procedure, nothing more. The point to land here: they don't need to know or type the skill's</a:t>
-            </a:r>
-          </a:p>
-          <a:p>
-            <a:r>
-              <a:t>name to trigger it; describing the job in plain English is enough for Claude to recognize a</a:t>
-            </a:r>
-          </a:p>
-          <a:p>
-            <a:r>
-              <a:t>match. This is also a quiet preview of the continuity story — a skill is a runbook recipe that</a:t>
-            </a:r>
-          </a:p>
-          <a:p>
-            <a:r>
-              <a:t>doesn't live in one person's head.</a:t>
+              <a:t>This is today's proof point — don't rush past it. If the PR command fails, it's almost always</a:t>
+            </a:r>
+          </a:p>
+          <a:p>
+            <a:r>
+              <a:t>a sign-in issue (`az login` once per machine) or the commit didn't actually happen inside the</a:t>
+            </a:r>
+          </a:p>
+          <a:p>
+            <a:r>
+              <a:t>sandbox branch before opening the PR — ask Claude to check both in plain English.</a:t>
             </a:r>
           </a:p>
         </p:txBody>
@@ -1649,12 +1640,27 @@
           <a:lstStyle/>
           <a:p>
             <a:r>
-              <a:t>If the new row is missing, the fix per the skill's own troubleshooting note is to recheck the</a:t>
-            </a:r>
-          </a:p>
-          <a:p>
-            <a:r>
-              <a:t>new line for a typo and re-run — it only reports what it can actually read.</a:t>
+              <a:t>~15 minutes. Show the skill file itself first — name, plain description, a short numbered</a:t>
+            </a:r>
+          </a:p>
+          <a:p>
+            <a:r>
+              <a:t>procedure, nothing more. The point to land here: they don't need to know or type the skill's</a:t>
+            </a:r>
+          </a:p>
+          <a:p>
+            <a:r>
+              <a:t>name to trigger it; describing the job in plain English is enough for Claude to recognize a</a:t>
+            </a:r>
+          </a:p>
+          <a:p>
+            <a:r>
+              <a:t>match. This is also a quiet preview of the continuity story — a skill is a runbook recipe that</a:t>
+            </a:r>
+          </a:p>
+          <a:p>
+            <a:r>
+              <a:t>doesn't live in one person's head.</a:t>
             </a:r>
           </a:p>
         </p:txBody>
@@ -1724,22 +1730,12 @@
           <a:lstStyle/>
           <a:p>
             <a:r>
-              <a:t>~15 minutes. Connecting the MCP server itself is normally a one-time setup step a facilitator</a:t>
-            </a:r>
-          </a:p>
-          <a:p>
-            <a:r>
-              <a:t>or IT admin does ahead of time, the same way Module 1's account sign-in is — their job here is</a:t>
-            </a:r>
-          </a:p>
-          <a:p>
-            <a:r>
-              <a:t>just to confirm it works, not to configure it live. If the answer looks like the wrong project,</a:t>
-            </a:r>
-          </a:p>
-          <a:p>
-            <a:r>
-              <a:t>ask Claude which Azure DevOps project it's connected to.</a:t>
+              <a:t>If the new row is missing, the fix per the skill's own troubleshooting note is to recheck the</a:t>
+            </a:r>
+          </a:p>
+          <a:p>
+            <a:r>
+              <a:t>new line for a typo and re-run — it only reports what it can actually read.</a:t>
             </a:r>
           </a:p>
         </p:txBody>
@@ -1809,12 +1805,22 @@
           <a:lstStyle/>
           <a:p>
             <a:r>
-              <a:t>This is the moment that usually lands hardest for a non-technical room: they asked a question</a:t>
-            </a:r>
-          </a:p>
-          <a:p>
-            <a:r>
-              <a:t>in plain English and got their own real, live data back, without touching the Azure DevOps UI.</a:t>
+              <a:t>~15 minutes. Connecting the MCP server itself is normally a one-time setup step a facilitator</a:t>
+            </a:r>
+          </a:p>
+          <a:p>
+            <a:r>
+              <a:t>or IT admin does ahead of time, the same way Module 1's account sign-in is — their job here is</a:t>
+            </a:r>
+          </a:p>
+          <a:p>
+            <a:r>
+              <a:t>just to confirm it works, not to configure it live. If the answer looks like the wrong project,</a:t>
+            </a:r>
+          </a:p>
+          <a:p>
+            <a:r>
+              <a:t>ask Claude which Azure DevOps project it's connected to.</a:t>
             </a:r>
           </a:p>
         </p:txBody>
@@ -1884,17 +1890,12 @@
           <a:lstStyle/>
           <a:p>
             <a:r>
-              <a:t>Recap before moving into Continuity &amp; Governance. Everything from here is stakeholder-facing —</a:t>
-            </a:r>
-          </a:p>
-          <a:p>
-            <a:r>
-              <a:t>if a security or leadership attendee is joining only for this part, this is a natural point for</a:t>
-            </a:r>
-          </a:p>
-          <a:p>
-            <a:r>
-              <a:t>them to join the room.</a:t>
+              <a:t>This is the moment that usually lands hardest for a non-technical room: they asked a question</a:t>
+            </a:r>
+          </a:p>
+          <a:p>
+            <a:r>
+              <a:t>in plain English and got their own real, live data back, without touching the Azure DevOps UI.</a:t>
             </a:r>
           </a:p>
         </p:txBody>
@@ -1964,17 +1965,17 @@
           <a:lstStyle/>
           <a:p>
             <a:r>
-              <a:t>~15 minutes, standalone. This section doesn't assume the audience sat through Sessions 1–2 — it</a:t>
-            </a:r>
-          </a:p>
-          <a:p>
-            <a:r>
-              <a:t>stands alone for a security or leadership reader who was never in the room. If replaying this</a:t>
-            </a:r>
-          </a:p>
-          <a:p>
-            <a:r>
-              <a:t>separately, the doc and the repo evidence behind it are enough on their own.</a:t>
+              <a:t>Recap before moving into Continuity &amp; Governance. Everything from here is stakeholder-facing —</a:t>
+            </a:r>
+          </a:p>
+          <a:p>
+            <a:r>
+              <a:t>if a security or leadership attendee is joining only for this part, this is a natural point for</a:t>
+            </a:r>
+          </a:p>
+          <a:p>
+            <a:r>
+              <a:t>them to join the room.</a:t>
             </a:r>
           </a:p>
         </p:txBody>
@@ -2044,22 +2045,17 @@
           <a:lstStyle/>
           <a:p>
             <a:r>
-              <a:t>~2 minutes. Land this plainly: one engineer writes a script, understands its quirks, and keeps</a:t>
-            </a:r>
-          </a:p>
-          <a:p>
-            <a:r>
-              <a:t>the rest in their head — why a step exists, what to check before changing it, how to stand it</a:t>
-            </a:r>
-          </a:p>
-          <a:p>
-            <a:r>
-              <a:t>up again from nothing. The script is fine. It's everything around it that was never written</a:t>
-            </a:r>
-          </a:p>
-          <a:p>
-            <a:r>
-              <a:t>down that a governance review correctly flags as a single point of failure.</a:t>
+              <a:t>~15 minutes, standalone. This section doesn't assume the audience sat through Sessions 1–2 — it</a:t>
+            </a:r>
+          </a:p>
+          <a:p>
+            <a:r>
+              <a:t>stands alone for a security or leadership reader who was never in the room. If replaying this</a:t>
+            </a:r>
+          </a:p>
+          <a:p>
+            <a:r>
+              <a:t>separately, the doc and the repo evidence behind it are enough on their own.</a:t>
             </a:r>
           </a:p>
         </p:txBody>
@@ -2129,22 +2125,22 @@
           <a:lstStyle/>
           <a:p>
             <a:r>
-              <a:t>~5 minutes. Every one of these six pairings is naming something Sessions 1–2 already produced —</a:t>
-            </a:r>
-          </a:p>
-          <a:p>
-            <a:r>
-              <a:t>nothing new to build. The whole answer to bus factor in one line: move the knowledge out of a</a:t>
-            </a:r>
-          </a:p>
-          <a:p>
-            <a:r>
-              <a:t>head and into the repo, where it survives whoever wrote it. A second person reading the same</a:t>
-            </a:r>
-          </a:p>
-          <a:p>
-            <a:r>
-              <a:t>files gets the same context Claude does.</a:t>
+              <a:t>~2 minutes. Land this plainly: one engineer writes a script, understands its quirks, and keeps</a:t>
+            </a:r>
+          </a:p>
+          <a:p>
+            <a:r>
+              <a:t>the rest in their head — why a step exists, what to check before changing it, how to stand it</a:t>
+            </a:r>
+          </a:p>
+          <a:p>
+            <a:r>
+              <a:t>up again from nothing. The script is fine. It's everything around it that was never written</a:t>
+            </a:r>
+          </a:p>
+          <a:p>
+            <a:r>
+              <a:t>down that a governance review correctly flags as a single point of failure.</a:t>
             </a:r>
           </a:p>
         </p:txBody>
@@ -2214,27 +2210,22 @@
           <a:lstStyle/>
           <a:p>
             <a:r>
-              <a:t>~4 minutes. A concern-to-artifact table is a claim; this is the test that backs it instead of</a:t>
-            </a:r>
-          </a:p>
-          <a:p>
-            <a:r>
-              <a:t>asking anyone to take it on faith. Hand a clean machine, the repo URL, and this kit to the</a:t>
-            </a:r>
-          </a:p>
-          <a:p>
-            <a:r>
-              <a:t>backup owner — or better, someone who was never in the room — and see how far they get with no</a:t>
-            </a:r>
-          </a:p>
-          <a:p>
-            <a:r>
-              <a:t>"just ask me if you get stuck." Getting stuck isn't a failure of the person; it's a gap in the</a:t>
-            </a:r>
-          </a:p>
-          <a:p>
-            <a:r>
-              <a:t>written runbook, fixed at that exact step, then re-tested.</a:t>
+              <a:t>~5 minutes. Every one of these six pairings is naming something Sessions 1–2 already produced —</a:t>
+            </a:r>
+          </a:p>
+          <a:p>
+            <a:r>
+              <a:t>nothing new to build. The whole answer to bus factor in one line: move the knowledge out of a</a:t>
+            </a:r>
+          </a:p>
+          <a:p>
+            <a:r>
+              <a:t>head and into the repo, where it survives whoever wrote it. A second person reading the same</a:t>
+            </a:r>
+          </a:p>
+          <a:p>
+            <a:r>
+              <a:t>files gets the same context Claude does.</a:t>
             </a:r>
           </a:p>
         </p:txBody>
@@ -2304,17 +2295,27 @@
           <a:lstStyle/>
           <a:p>
             <a:r>
-              <a:t>~2 minutes. One rule, repeated everywhere it applies. The pre-commit hook catches a mistake</a:t>
-            </a:r>
-          </a:p>
-          <a:p>
-            <a:r>
-              <a:t>before it exists anywhere shared, not after. Read-only keys mean a leaked or misused key can't</a:t>
-            </a:r>
-          </a:p>
-          <a:p>
-            <a:r>
-              <a:t>write or delete anything, even in the worst case.</a:t>
+              <a:t>~4 minutes. A concern-to-artifact table is a claim; this is the test that backs it instead of</a:t>
+            </a:r>
+          </a:p>
+          <a:p>
+            <a:r>
+              <a:t>asking anyone to take it on faith. Hand a clean machine, the repo URL, and this kit to the</a:t>
+            </a:r>
+          </a:p>
+          <a:p>
+            <a:r>
+              <a:t>backup owner — or better, someone who was never in the room — and see how far they get with no</a:t>
+            </a:r>
+          </a:p>
+          <a:p>
+            <a:r>
+              <a:t>"just ask me if you get stuck." Getting stuck isn't a failure of the person; it's a gap in the</a:t>
+            </a:r>
+          </a:p>
+          <a:p>
+            <a:r>
+              <a:t>written runbook, fixed at that exact step, then re-tested.</a:t>
             </a:r>
           </a:p>
         </p:txBody>
@@ -2469,22 +2470,17 @@
           <a:lstStyle/>
           <a:p>
             <a:r>
-              <a:t>~2 minutes, read close to verbatim — this is the one slide written to stand completely on its</a:t>
-            </a:r>
-          </a:p>
-          <a:p>
-            <a:r>
-              <a:t>own for a stakeholder who reads nothing else in this deck. In short: the knowledge this project</a:t>
-            </a:r>
-          </a:p>
-          <a:p>
-            <a:r>
-              <a:t>depends on is captured in artifacts that outlive any one person, and that claim has been proven</a:t>
-            </a:r>
-          </a:p>
-          <a:p>
-            <a:r>
-              <a:t>with a test, not taken on trust.</a:t>
+              <a:t>~2 minutes. One rule, repeated everywhere it applies. The pre-commit hook catches a mistake</a:t>
+            </a:r>
+          </a:p>
+          <a:p>
+            <a:r>
+              <a:t>before it exists anywhere shared, not after. Read-only keys mean a leaked or misused key can't</a:t>
+            </a:r>
+          </a:p>
+          <a:p>
+            <a:r>
+              <a:t>write or delete anything, even in the worst case.</a:t>
             </a:r>
           </a:p>
         </p:txBody>
@@ -2554,17 +2550,22 @@
           <a:lstStyle/>
           <a:p>
             <a:r>
-              <a:t>Point at the printed one-page cheat sheet every attendee keeps — this slide is the same content,</a:t>
-            </a:r>
-          </a:p>
-          <a:p>
-            <a:r>
-              <a:t>condensed further. This is a glance card for their first week of real use, not a teaching doc;</a:t>
-            </a:r>
-          </a:p>
-          <a:p>
-            <a:r>
-              <a:t>the full story is what Sessions 1 and 2 already covered.</a:t>
+              <a:t>~2 minutes, read close to verbatim — this is the one slide written to stand completely on its</a:t>
+            </a:r>
+          </a:p>
+          <a:p>
+            <a:r>
+              <a:t>own for a stakeholder who reads nothing else in this deck. In short: the knowledge this project</a:t>
+            </a:r>
+          </a:p>
+          <a:p>
+            <a:r>
+              <a:t>depends on is captured in artifacts that outlive any one person, and that claim has been proven</a:t>
+            </a:r>
+          </a:p>
+          <a:p>
+            <a:r>
+              <a:t>with a test, not taken on trust.</a:t>
             </a:r>
           </a:p>
         </p:txBody>
@@ -2634,17 +2635,17 @@
           <a:lstStyle/>
           <a:p>
             <a:r>
-              <a:t>Set the expectation that this kit doesn't expire after today — every document stays with them</a:t>
-            </a:r>
-          </a:p>
-          <a:p>
-            <a:r>
-              <a:t>as a leave-behind reference. Suggest a concrete next step: pick one small, real, low-stakes</a:t>
-            </a:r>
-          </a:p>
-          <a:p>
-            <a:r>
-              <a:t>piece of work and run the full loop on it themselves within the next week, while it's fresh.</a:t>
+              <a:t>Point at the printed one-page cheat sheet every attendee keeps — this slide is the same content,</a:t>
+            </a:r>
+          </a:p>
+          <a:p>
+            <a:r>
+              <a:t>condensed further. This is a glance card for their first week of real use, not a teaching doc;</a:t>
+            </a:r>
+          </a:p>
+          <a:p>
+            <a:r>
+              <a:t>the full story is what Sessions 1 and 2 already covered.</a:t>
             </a:r>
           </a:p>
         </p:txBody>
@@ -2714,6 +2715,86 @@
           <a:lstStyle/>
           <a:p>
             <a:r>
+              <a:t>Set the expectation that this kit doesn't expire after today — every document stays with them</a:t>
+            </a:r>
+          </a:p>
+          <a:p>
+            <a:r>
+              <a:t>as a leave-behind reference. Suggest a concrete next step: pick one small, real, low-stakes</a:t>
+            </a:r>
+          </a:p>
+          <a:p>
+            <a:r>
+              <a:t>piece of work and run the full loop on it themselves within the next week, while it's fresh.</a:t>
+            </a:r>
+          </a:p>
+        </p:txBody>
+      </p:sp>
+      <p:sp>
+        <p:nvSpPr>
+          <p:cNvPr id="4" name="Slide Number Placeholder 3"/>
+          <p:cNvSpPr>
+            <a:spLocks noGrp="1"/>
+          </p:cNvSpPr>
+          <p:nvPr>
+            <p:ph type="sldNum" idx="5" sz="quarter"/>
+          </p:nvPr>
+        </p:nvSpPr>
+        <p:spPr/>
+      </p:sp>
+    </p:spTree>
+  </p:cSld>
+  <p:clrMapOvr>
+    <a:masterClrMapping/>
+  </p:clrMapOvr>
+</p:notes>
+</file>
+
+<file path=ppt/notesSlides/notesSlide34.xml><?xml version="1.0" encoding="utf-8"?>
+<p:notes xmlns:a="http://schemas.openxmlformats.org/drawingml/2006/main" xmlns:p="http://schemas.openxmlformats.org/presentationml/2006/main" xmlns:r="http://schemas.openxmlformats.org/officeDocument/2006/relationships">
+  <p:cSld>
+    <p:spTree>
+      <p:nvGrpSpPr>
+        <p:cNvPr id="1" name=""/>
+        <p:cNvGrpSpPr/>
+        <p:nvPr/>
+      </p:nvGrpSpPr>
+      <p:grpSpPr>
+        <a:xfrm>
+          <a:off x="0" y="0"/>
+          <a:ext cx="0" cy="0"/>
+          <a:chOff x="0" y="0"/>
+          <a:chExt cx="0" cy="0"/>
+        </a:xfrm>
+      </p:grpSpPr>
+      <p:sp>
+        <p:nvSpPr>
+          <p:cNvPr id="2" name="Slide Image Placeholder 1"/>
+          <p:cNvSpPr>
+            <a:spLocks noGrp="1"/>
+          </p:cNvSpPr>
+          <p:nvPr>
+            <p:ph type="sldImg" idx="2"/>
+          </p:nvPr>
+        </p:nvSpPr>
+        <p:spPr/>
+      </p:sp>
+      <p:sp>
+        <p:nvSpPr>
+          <p:cNvPr id="3" name="Notes Placeholder 2"/>
+          <p:cNvSpPr>
+            <a:spLocks noGrp="1"/>
+          </p:cNvSpPr>
+          <p:nvPr>
+            <p:ph type="body" idx="3" sz="quarter"/>
+          </p:nvPr>
+        </p:nvSpPr>
+        <p:spPr/>
+        <p:txBody>
+          <a:bodyPr/>
+          <a:lstStyle/>
+          <a:p>
+            <a:r>
               <a:t>Close on the spine one more time — it's the whole kit in one sentence, and it's worth them</a:t>
             </a:r>
           </a:p>
@@ -2879,27 +2960,42 @@
           <a:lstStyle/>
           <a:p>
             <a:r>
-              <a:t>Don't read all ten aloud word for word — that's what the printed glossary (00-glossary.md) is</a:t>
-            </a:r>
-          </a:p>
-          <a:p>
-            <a:r>
-              <a:t>for, and every attendee keeps it. Instead, reassure: every one of these has a plain-English</a:t>
-            </a:r>
-          </a:p>
-          <a:p>
-            <a:r>
-              <a:t>definition and a Windows-admin analogy in the glossary, and nothing later in this deck uses a</a:t>
-            </a:r>
-          </a:p>
-          <a:p>
-            <a:r>
-              <a:t>term without having introduced it here first. Point at the glossary page itself as the thing</a:t>
-            </a:r>
-          </a:p>
-          <a:p>
-            <a:r>
-              <a:t>they'll actually flip back to, not this slide.</a:t>
+              <a:t>Don't read these aloud word for word — that's what the printed glossary (00-glossary.md) is for,</a:t>
+            </a:r>
+          </a:p>
+          <a:p>
+            <a:r>
+              <a:t>and every attendee keeps it. Fuller definitions + Windows-admin analogies live there: Claude Code</a:t>
+            </a:r>
+          </a:p>
+          <a:p>
+            <a:r>
+              <a:t>is like calling the help desk and describing what you need, instead of configuring it yourself by</a:t>
+            </a:r>
+          </a:p>
+          <a:p>
+            <a:r>
+              <a:t>hand. A terminal is like a PowerShell window — same idea, just where you and Claude talk. A repo</a:t>
+            </a:r>
+          </a:p>
+          <a:p>
+            <a:r>
+              <a:t>is like a shared network folder that remembers every version of every file. A commit is like a</a:t>
+            </a:r>
+          </a:p>
+          <a:p>
+            <a:r>
+              <a:t>labeled system checkpoint — "before patch Tuesday" — you can always come back to. A pull request</a:t>
+            </a:r>
+          </a:p>
+          <a:p>
+            <a:r>
+              <a:t>is like a change-request ticket in change management — nothing goes live until it's reviewed and</a:t>
+            </a:r>
+          </a:p>
+          <a:p>
+            <a:r>
+              <a:t>approved. Nothing later in this deck uses a term without having introduced it here first.</a:t>
             </a:r>
           </a:p>
         </p:txBody>
@@ -2969,22 +3065,42 @@
           <a:lstStyle/>
           <a:p>
             <a:r>
-              <a:t>Set expectations for the whole day: everything hands-on — the plan, the script, the pull</a:t>
-            </a:r>
-          </a:p>
-          <a:p>
-            <a:r>
-              <a:t>request, the skill — is built against this one small, obviously-fake project. Nothing here is</a:t>
-            </a:r>
-          </a:p>
-          <a:p>
-            <a:r>
-              <a:t>their real work, and nothing about their real project appears anywhere in this kit. That's</a:t>
-            </a:r>
-          </a:p>
-          <a:p>
-            <a:r>
-              <a:t>deliberate: it means this same deck and kit gets reused for the next client unchanged.</a:t>
+              <a:t>Second half of the glossary — same rule: point at the printed glossary (00-glossary.md), don't</a:t>
+            </a:r>
+          </a:p>
+          <a:p>
+            <a:r>
+              <a:t>read these aloud. Fuller definitions + Windows-admin analogies live there: a branch/worktree is</a:t>
+            </a:r>
+          </a:p>
+          <a:p>
+            <a:r>
+              <a:t>like testing a change on a lab VM before you touch the production server. `CLAUDE.md` is like a</a:t>
+            </a:r>
+          </a:p>
+          <a:p>
+            <a:r>
+              <a:t>runbook or standard operating procedure a new tech reads on day one — except Claude reads it every</a:t>
+            </a:r>
+          </a:p>
+          <a:p>
+            <a:r>
+              <a:t>single time. Memory is like a ticketing system's notes field that follows the issue (or the</a:t>
+            </a:r>
+          </a:p>
+          <a:p>
+            <a:r>
+              <a:t>person) across every future call. A skill is like a saved PowerShell script or a documented</a:t>
+            </a:r>
+          </a:p>
+          <a:p>
+            <a:r>
+              <a:t>runbook recipe — write it once, run it every time after. MCP is like giving the help desk read</a:t>
+            </a:r>
+          </a:p>
+          <a:p>
+            <a:r>
+              <a:t>access to your ticketing system, instead of you copy-pasting ticket details into an email.</a:t>
             </a:r>
           </a:p>
         </p:txBody>
@@ -3054,17 +3170,22 @@
           <a:lstStyle/>
           <a:p>
             <a:r>
-              <a:t>Section transition. Session 1 is Modules 0 through 3, roughly 45 to 60 minutes, most of it in</a:t>
-            </a:r>
-          </a:p>
-          <a:p>
-            <a:r>
-              <a:t>Module 1 where install and sign-in issues are most likely to eat time. By the end, every</a:t>
-            </a:r>
-          </a:p>
-          <a:p>
-            <a:r>
-              <a:t>attendee has a project-aware Claude Code with a working rulebook and memory.</a:t>
+              <a:t>Set expectations for the whole day: everything hands-on — the plan, the script, the pull</a:t>
+            </a:r>
+          </a:p>
+          <a:p>
+            <a:r>
+              <a:t>request, the skill — is built against this one small, obviously-fake project. Nothing here is</a:t>
+            </a:r>
+          </a:p>
+          <a:p>
+            <a:r>
+              <a:t>their real work, and nothing about their real project appears anywhere in this kit. That's</a:t>
+            </a:r>
+          </a:p>
+          <a:p>
+            <a:r>
+              <a:t>deliberate: it means this same deck and kit gets reused for the next client unchanged.</a:t>
             </a:r>
           </a:p>
         </p:txBody>
@@ -3134,27 +3255,17 @@
           <a:lstStyle/>
           <a:p>
             <a:r>
-              <a:t>~20 minutes. Confirm before the session that every attendee's Enterprise account provisioning</a:t>
-            </a:r>
-          </a:p>
-          <a:p>
-            <a:r>
-              <a:t>method (SSO vs. a console-issued key) is already known — don't guess this live, and don't try</a:t>
-            </a:r>
-          </a:p>
-          <a:p>
-            <a:r>
-              <a:t>to work around a PowerShell script-execution policy yourselves; that's an IT policy question.</a:t>
-            </a:r>
-          </a:p>
-          <a:p>
-            <a:r>
-              <a:t>The VS Code extension gives them a chat panel, a plan they can review before Claude acts, and a</a:t>
-            </a:r>
-          </a:p>
-          <a:p>
-            <a:r>
-              <a:t>side-by-side diff view — same Claude Code, just inside the editor instead of a separate window.</a:t>
+              <a:t>Section transition. Session 1 is Modules 0 through 3, roughly 45 to 60 minutes, most of it in</a:t>
+            </a:r>
+          </a:p>
+          <a:p>
+            <a:r>
+              <a:t>Module 1 where install and sign-in issues are most likely to eat time. By the end, every</a:t>
+            </a:r>
+          </a:p>
+          <a:p>
+            <a:r>
+              <a:t>attendee has a project-aware Claude Code with a working rulebook and memory.</a:t>
             </a:r>
           </a:p>
         </p:txBody>
@@ -3224,17 +3335,27 @@
           <a:lstStyle/>
           <a:p>
             <a:r>
-              <a:t>Don't move on until every attendee has actually done this themselves, not just watched you do</a:t>
-            </a:r>
-          </a:p>
-          <a:p>
-            <a:r>
-              <a:t>it. If `claude` isn't recognized, closing and reopening the terminal once usually fixes it —</a:t>
-            </a:r>
-          </a:p>
-          <a:p>
-            <a:r>
-              <a:t>that refreshes the list of commands it knows about.</a:t>
+              <a:t>~20 minutes. Confirm before the session that every attendee's Enterprise account provisioning</a:t>
+            </a:r>
+          </a:p>
+          <a:p>
+            <a:r>
+              <a:t>method (SSO vs. a console-issued key) is already known — don't guess this live, and don't try</a:t>
+            </a:r>
+          </a:p>
+          <a:p>
+            <a:r>
+              <a:t>to work around a PowerShell script-execution policy yourselves; that's an IT policy question.</a:t>
+            </a:r>
+          </a:p>
+          <a:p>
+            <a:r>
+              <a:t>The VS Code extension gives them a chat panel, a plan they can review before Claude acts, and a</a:t>
+            </a:r>
+          </a:p>
+          <a:p>
+            <a:r>
+              <a:t>side-by-side diff view — same Claude Code, just inside the editor instead of a separate window.</a:t>
             </a:r>
           </a:p>
         </p:txBody>
@@ -6419,7 +6540,7 @@
                   <a:srgbClr val="0A0A0A"/>
                 </a:solidFill>
               </a:rPr>
-              <a:t>Give Claude its rulebook</a:t>
+              <a:t>Checkpoint: say hello</a:t>
             </a:r>
           </a:p>
         </p:txBody>
@@ -6457,67 +6578,37 @@
                   <a:srgbClr val="0A0A0A"/>
                 </a:solidFill>
               </a:rPr>
-              <a:t>•  `CLAUDE.md` — standing rules Claude reads first, every time</a:t>
-            </a:r>
-          </a:p>
-          <a:p>
-            <a:pPr>
-              <a:spcAft>
-                <a:spcPts val="1000"/>
-              </a:spcAft>
-            </a:pPr>
-            <a:r>
-              <a:rPr sz="2200">
-                <a:solidFill>
-                  <a:srgbClr val="0A0A0A"/>
-                </a:solidFill>
-              </a:rPr>
-              <a:t>•  `PROJECT_CONTEXT.md` — the fuller story underneath it</a:t>
-            </a:r>
-          </a:p>
-          <a:p>
-            <a:pPr>
-              <a:spcAft>
-                <a:spcPts val="1000"/>
-              </a:spcAft>
-            </a:pPr>
-            <a:r>
-              <a:rPr sz="2200">
-                <a:solidFill>
-                  <a:srgbClr val="0A0A0A"/>
-                </a:solidFill>
-              </a:rPr>
-              <a:t>•  Model both on the Contoso example, then draft your own</a:t>
-            </a:r>
-          </a:p>
-          <a:p>
-            <a:pPr>
-              <a:spcAft>
-                <a:spcPts val="1000"/>
-              </a:spcAft>
-            </a:pPr>
-            <a:r>
-              <a:rPr sz="2200">
-                <a:solidFill>
-                  <a:srgbClr val="0A0A0A"/>
-                </a:solidFill>
-              </a:rPr>
-              <a:t>•  Read what Claude drafts before accepting it</a:t>
-            </a:r>
-          </a:p>
-          <a:p>
-            <a:pPr>
-              <a:spcAft>
-                <a:spcPts val="1000"/>
-              </a:spcAft>
-            </a:pPr>
-            <a:r>
-              <a:rPr sz="2200">
-                <a:solidFill>
-                  <a:srgbClr val="0A0A0A"/>
-                </a:solidFill>
-              </a:rPr>
-              <a:t>•  Correct anything wrong, in plain English</a:t>
+              <a:t>•  Typed "Hello" to Claude in a terminal</a:t>
+            </a:r>
+          </a:p>
+          <a:p>
+            <a:pPr>
+              <a:spcAft>
+                <a:spcPts val="1000"/>
+              </a:spcAft>
+            </a:pPr>
+            <a:r>
+              <a:rPr sz="2200">
+                <a:solidFill>
+                  <a:srgbClr val="0A0A0A"/>
+                </a:solidFill>
+              </a:rPr>
+              <a:t>•  Got a plain-English reply back</a:t>
+            </a:r>
+          </a:p>
+          <a:p>
+            <a:pPr>
+              <a:spcAft>
+                <a:spcPts val="1000"/>
+              </a:spcAft>
+            </a:pPr>
+            <a:r>
+              <a:rPr sz="2200">
+                <a:solidFill>
+                  <a:srgbClr val="0A0A0A"/>
+                </a:solidFill>
+              </a:rPr>
+              <a:t>•  That's the whole loop working end to end</a:t>
             </a:r>
           </a:p>
         </p:txBody>
@@ -6601,7 +6692,7 @@
                   <a:srgbClr val="0A0A0A"/>
                 </a:solidFill>
               </a:rPr>
-              <a:t>Checkpoint: what are we building?</a:t>
+              <a:t>Give Claude its rulebook</a:t>
             </a:r>
           </a:p>
         </p:txBody>
@@ -6639,37 +6730,67 @@
                   <a:srgbClr val="0A0A0A"/>
                 </a:solidFill>
               </a:rPr>
-              <a:t>•  Ask, in a new message: "What are we building?"</a:t>
-            </a:r>
-          </a:p>
-          <a:p>
-            <a:pPr>
-              <a:spcAft>
-                <a:spcPts val="1000"/>
-              </a:spcAft>
-            </a:pPr>
-            <a:r>
-              <a:rPr sz="2200">
-                <a:solidFill>
-                  <a:srgbClr val="0A0A0A"/>
-                </a:solidFill>
-              </a:rPr>
-              <a:t>•  It should answer using your own `PROJECT_CONTEXT.md`</a:t>
-            </a:r>
-          </a:p>
-          <a:p>
-            <a:pPr>
-              <a:spcAft>
-                <a:spcPts val="1000"/>
-              </a:spcAft>
-            </a:pPr>
-            <a:r>
-              <a:rPr sz="2200">
-                <a:solidFill>
-                  <a:srgbClr val="0A0A0A"/>
-                </a:solidFill>
-              </a:rPr>
-              <a:t>•  Correctly, in its own words — not Contoso's, not generic</a:t>
+              <a:t>•  `CLAUDE.md` — standing rules Claude reads first, every time</a:t>
+            </a:r>
+          </a:p>
+          <a:p>
+            <a:pPr>
+              <a:spcAft>
+                <a:spcPts val="1000"/>
+              </a:spcAft>
+            </a:pPr>
+            <a:r>
+              <a:rPr sz="2200">
+                <a:solidFill>
+                  <a:srgbClr val="0A0A0A"/>
+                </a:solidFill>
+              </a:rPr>
+              <a:t>•  `PROJECT_CONTEXT.md` — the fuller story underneath it</a:t>
+            </a:r>
+          </a:p>
+          <a:p>
+            <a:pPr>
+              <a:spcAft>
+                <a:spcPts val="1000"/>
+              </a:spcAft>
+            </a:pPr>
+            <a:r>
+              <a:rPr sz="2200">
+                <a:solidFill>
+                  <a:srgbClr val="0A0A0A"/>
+                </a:solidFill>
+              </a:rPr>
+              <a:t>•  Model both on the Contoso example, then draft your own</a:t>
+            </a:r>
+          </a:p>
+          <a:p>
+            <a:pPr>
+              <a:spcAft>
+                <a:spcPts val="1000"/>
+              </a:spcAft>
+            </a:pPr>
+            <a:r>
+              <a:rPr sz="2200">
+                <a:solidFill>
+                  <a:srgbClr val="0A0A0A"/>
+                </a:solidFill>
+              </a:rPr>
+              <a:t>•  Read what Claude drafts before accepting it</a:t>
+            </a:r>
+          </a:p>
+          <a:p>
+            <a:pPr>
+              <a:spcAft>
+                <a:spcPts val="1000"/>
+              </a:spcAft>
+            </a:pPr>
+            <a:r>
+              <a:rPr sz="2200">
+                <a:solidFill>
+                  <a:srgbClr val="0A0A0A"/>
+                </a:solidFill>
+              </a:rPr>
+              <a:t>•  Correct anything wrong, in plain English</a:t>
             </a:r>
           </a:p>
         </p:txBody>
@@ -6753,7 +6874,7 @@
                   <a:srgbClr val="0A0A0A"/>
                 </a:solidFill>
               </a:rPr>
-              <a:t>Give Claude a memory</a:t>
+              <a:t>Checkpoint: what are we building?</a:t>
             </a:r>
           </a:p>
         </p:txBody>
@@ -6791,67 +6912,37 @@
                   <a:srgbClr val="0A0A0A"/>
                 </a:solidFill>
               </a:rPr>
-              <a:t>•  Memory = notes Claude keeps between conversations</a:t>
-            </a:r>
-          </a:p>
-          <a:p>
-            <a:pPr>
-              <a:spcAft>
-                <a:spcPts val="1000"/>
-              </a:spcAft>
-            </a:pPr>
-            <a:r>
-              <a:rPr sz="2200">
-                <a:solidFill>
-                  <a:srgbClr val="0A0A0A"/>
-                </a:solidFill>
-              </a:rPr>
-              <a:t>•  Tell Claude one true, useful fact to remember</a:t>
-            </a:r>
-          </a:p>
-          <a:p>
-            <a:pPr>
-              <a:spcAft>
-                <a:spcPts val="1000"/>
-              </a:spcAft>
-            </a:pPr>
-            <a:r>
-              <a:rPr sz="2200">
-                <a:solidFill>
-                  <a:srgbClr val="0A0A0A"/>
-                </a:solidFill>
-              </a:rPr>
-              <a:t>•  Claude saves it — you never hand-edit a file</a:t>
-            </a:r>
-          </a:p>
-          <a:p>
-            <a:pPr>
-              <a:spcAft>
-                <a:spcPts val="1000"/>
-              </a:spcAft>
-            </a:pPr>
-            <a:r>
-              <a:rPr sz="2200">
-                <a:solidFill>
-                  <a:srgbClr val="0A0A0A"/>
-                </a:solidFill>
-              </a:rPr>
-              <a:t>•  Ask "where did you save that?" to see it</a:t>
-            </a:r>
-          </a:p>
-          <a:p>
-            <a:pPr>
-              <a:spcAft>
-                <a:spcPts val="1000"/>
-              </a:spcAft>
-            </a:pPr>
-            <a:r>
-              <a:rPr sz="2200">
-                <a:solidFill>
-                  <a:srgbClr val="0A0A0A"/>
-                </a:solidFill>
-              </a:rPr>
-              <a:t>•  `MEMORY.md` is the index, one line per saved fact</a:t>
+              <a:t>•  Ask, in a new message: "What are we building?"</a:t>
+            </a:r>
+          </a:p>
+          <a:p>
+            <a:pPr>
+              <a:spcAft>
+                <a:spcPts val="1000"/>
+              </a:spcAft>
+            </a:pPr>
+            <a:r>
+              <a:rPr sz="2200">
+                <a:solidFill>
+                  <a:srgbClr val="0A0A0A"/>
+                </a:solidFill>
+              </a:rPr>
+              <a:t>•  It should answer using your own `PROJECT_CONTEXT.md`</a:t>
+            </a:r>
+          </a:p>
+          <a:p>
+            <a:pPr>
+              <a:spcAft>
+                <a:spcPts val="1000"/>
+              </a:spcAft>
+            </a:pPr>
+            <a:r>
+              <a:rPr sz="2200">
+                <a:solidFill>
+                  <a:srgbClr val="0A0A0A"/>
+                </a:solidFill>
+              </a:rPr>
+              <a:t>•  Correctly, in its own words — not Contoso's, not generic</a:t>
             </a:r>
           </a:p>
         </p:txBody>
@@ -6935,7 +7026,7 @@
                   <a:srgbClr val="0A0A0A"/>
                 </a:solidFill>
               </a:rPr>
-              <a:t>Checkpoint: a fresh chat remembers</a:t>
+              <a:t>Give Claude a memory</a:t>
             </a:r>
           </a:p>
         </p:txBody>
@@ -6973,37 +7064,67 @@
                   <a:srgbClr val="0A0A0A"/>
                 </a:solidFill>
               </a:rPr>
-              <a:t>•  Close the session entirely, start a brand-new chat</a:t>
-            </a:r>
-          </a:p>
-          <a:p>
-            <a:pPr>
-              <a:spcAft>
-                <a:spcPts val="1000"/>
-              </a:spcAft>
-            </a:pPr>
-            <a:r>
-              <a:rPr sz="2200">
-                <a:solidFill>
-                  <a:srgbClr val="0A0A0A"/>
-                </a:solidFill>
-              </a:rPr>
-              <a:t>•  Ask: "What do you remember about us?"</a:t>
-            </a:r>
-          </a:p>
-          <a:p>
-            <a:pPr>
-              <a:spcAft>
-                <a:spcPts val="1000"/>
-              </a:spcAft>
-            </a:pPr>
-            <a:r>
-              <a:rPr sz="2200">
-                <a:solidFill>
-                  <a:srgbClr val="0A0A0A"/>
-                </a:solidFill>
-              </a:rPr>
-              <a:t>•  Claude answers correctly, unprompted</a:t>
+              <a:t>•  Memory = notes Claude keeps between conversations</a:t>
+            </a:r>
+          </a:p>
+          <a:p>
+            <a:pPr>
+              <a:spcAft>
+                <a:spcPts val="1000"/>
+              </a:spcAft>
+            </a:pPr>
+            <a:r>
+              <a:rPr sz="2200">
+                <a:solidFill>
+                  <a:srgbClr val="0A0A0A"/>
+                </a:solidFill>
+              </a:rPr>
+              <a:t>•  Tell Claude one true, useful fact to remember</a:t>
+            </a:r>
+          </a:p>
+          <a:p>
+            <a:pPr>
+              <a:spcAft>
+                <a:spcPts val="1000"/>
+              </a:spcAft>
+            </a:pPr>
+            <a:r>
+              <a:rPr sz="2200">
+                <a:solidFill>
+                  <a:srgbClr val="0A0A0A"/>
+                </a:solidFill>
+              </a:rPr>
+              <a:t>•  Claude saves it — you never hand-edit a file</a:t>
+            </a:r>
+          </a:p>
+          <a:p>
+            <a:pPr>
+              <a:spcAft>
+                <a:spcPts val="1000"/>
+              </a:spcAft>
+            </a:pPr>
+            <a:r>
+              <a:rPr sz="2200">
+                <a:solidFill>
+                  <a:srgbClr val="0A0A0A"/>
+                </a:solidFill>
+              </a:rPr>
+              <a:t>•  Ask "where did you save that?" to see it</a:t>
+            </a:r>
+          </a:p>
+          <a:p>
+            <a:pPr>
+              <a:spcAft>
+                <a:spcPts val="1000"/>
+              </a:spcAft>
+            </a:pPr>
+            <a:r>
+              <a:rPr sz="2200">
+                <a:solidFill>
+                  <a:srgbClr val="0A0A0A"/>
+                </a:solidFill>
+              </a:rPr>
+              <a:t>•  `MEMORY.md` is the index, one line per saved fact</a:t>
             </a:r>
           </a:p>
         </p:txBody>
@@ -7087,7 +7208,7 @@
                   <a:srgbClr val="0A0A0A"/>
                 </a:solidFill>
               </a:rPr>
-              <a:t>Session 1 recap</a:t>
+              <a:t>Checkpoint: a fresh chat remembers</a:t>
             </a:r>
           </a:p>
         </p:txBody>
@@ -7125,52 +7246,37 @@
                   <a:srgbClr val="0A0A0A"/>
                 </a:solidFill>
               </a:rPr>
-              <a:t>•  5 pieces, 2 down: rulebook + memory</a:t>
-            </a:r>
-          </a:p>
-          <a:p>
-            <a:pPr>
-              <a:spcAft>
-                <a:spcPts val="1000"/>
-              </a:spcAft>
-            </a:pPr>
-            <a:r>
-              <a:rPr sz="2200">
-                <a:solidFill>
-                  <a:srgbClr val="0A0A0A"/>
-                </a:solidFill>
-              </a:rPr>
-              <a:t>•  Claude now knows your project, and remembers</a:t>
-            </a:r>
-          </a:p>
-          <a:p>
-            <a:pPr>
-              <a:spcAft>
-                <a:spcPts val="1000"/>
-              </a:spcAft>
-            </a:pPr>
-            <a:r>
-              <a:rPr sz="2200">
-                <a:solidFill>
-                  <a:srgbClr val="0A0A0A"/>
-                </a:solidFill>
-              </a:rPr>
-              <a:t>•  Session 2 covers the daily loop, sandbox, skills, tools</a:t>
-            </a:r>
-          </a:p>
-          <a:p>
-            <a:pPr>
-              <a:spcAft>
-                <a:spcPts val="1000"/>
-              </a:spcAft>
-            </a:pPr>
-            <a:r>
-              <a:rPr sz="2200">
-                <a:solidFill>
-                  <a:srgbClr val="0A0A0A"/>
-                </a:solidFill>
-              </a:rPr>
-              <a:t>•  Keep the spine in mind: you check, you decide</a:t>
+              <a:t>•  Close the session entirely, start a brand-new chat</a:t>
+            </a:r>
+          </a:p>
+          <a:p>
+            <a:pPr>
+              <a:spcAft>
+                <a:spcPts val="1000"/>
+              </a:spcAft>
+            </a:pPr>
+            <a:r>
+              <a:rPr sz="2200">
+                <a:solidFill>
+                  <a:srgbClr val="0A0A0A"/>
+                </a:solidFill>
+              </a:rPr>
+              <a:t>•  Ask: "What do you remember about us?"</a:t>
+            </a:r>
+          </a:p>
+          <a:p>
+            <a:pPr>
+              <a:spcAft>
+                <a:spcPts val="1000"/>
+              </a:spcAft>
+            </a:pPr>
+            <a:r>
+              <a:rPr sz="2200">
+                <a:solidFill>
+                  <a:srgbClr val="0A0A0A"/>
+                </a:solidFill>
+              </a:rPr>
+              <a:t>•  Claude answers correctly, unprompted</a:t>
             </a:r>
           </a:p>
         </p:txBody>
@@ -7217,8 +7323,8 @@
         </p:blipFill>
         <p:spPr>
           <a:xfrm>
-            <a:off x="548640" y="457200"/>
-            <a:ext cx="731520" cy="731520"/>
+            <a:off x="10607040" y="365760"/>
+            <a:ext cx="548640" cy="548640"/>
           </a:xfrm>
           <a:prstGeom prst="rect">
             <a:avLst/>
@@ -7233,7 +7339,7 @@
         </p:nvSpPr>
         <p:spPr>
           <a:xfrm>
-            <a:off x="640080" y="2926080"/>
+            <a:off x="640080" y="457200"/>
             <a:ext cx="10972800" cy="1828800"/>
           </a:xfrm>
           <a:prstGeom prst="rect">
@@ -7247,14 +7353,97 @@
           </a:bodyPr>
           <a:lstStyle/>
           <a:p>
-            <a:pPr algn="ctr"/>
-            <a:r>
-              <a:rPr sz="4000" b="1">
-                <a:solidFill>
-                  <a:srgbClr val="0A0A0A"/>
-                </a:solidFill>
-              </a:rPr>
-              <a:t>Session 2: Work With It</a:t>
+            <a:pPr algn="l"/>
+            <a:r>
+              <a:rPr sz="3200" b="1">
+                <a:solidFill>
+                  <a:srgbClr val="0A0A0A"/>
+                </a:solidFill>
+              </a:rPr>
+              <a:t>Session 1 recap</a:t>
+            </a:r>
+          </a:p>
+        </p:txBody>
+      </p:sp>
+      <p:sp>
+        <p:nvSpPr>
+          <p:cNvPr id="4" name="TextBox 3"/>
+          <p:cNvSpPr txBox="1"/>
+          <p:nvPr/>
+        </p:nvSpPr>
+        <p:spPr>
+          <a:xfrm>
+            <a:off x="822960" y="1828800"/>
+            <a:ext cx="10515600" cy="4114800"/>
+          </a:xfrm>
+          <a:prstGeom prst="rect">
+            <a:avLst/>
+          </a:prstGeom>
+          <a:noFill/>
+        </p:spPr>
+        <p:txBody>
+          <a:bodyPr wrap="square">
+            <a:spAutoFit/>
+          </a:bodyPr>
+          <a:lstStyle/>
+          <a:p>
+            <a:pPr>
+              <a:spcAft>
+                <a:spcPts val="1000"/>
+              </a:spcAft>
+            </a:pPr>
+            <a:r>
+              <a:rPr sz="2200">
+                <a:solidFill>
+                  <a:srgbClr val="0A0A0A"/>
+                </a:solidFill>
+              </a:rPr>
+              <a:t>•  5 pieces, 2 down: rulebook + memory</a:t>
+            </a:r>
+          </a:p>
+          <a:p>
+            <a:pPr>
+              <a:spcAft>
+                <a:spcPts val="1000"/>
+              </a:spcAft>
+            </a:pPr>
+            <a:r>
+              <a:rPr sz="2200">
+                <a:solidFill>
+                  <a:srgbClr val="0A0A0A"/>
+                </a:solidFill>
+              </a:rPr>
+              <a:t>•  Claude now knows your project, and remembers</a:t>
+            </a:r>
+          </a:p>
+          <a:p>
+            <a:pPr>
+              <a:spcAft>
+                <a:spcPts val="1000"/>
+              </a:spcAft>
+            </a:pPr>
+            <a:r>
+              <a:rPr sz="2200">
+                <a:solidFill>
+                  <a:srgbClr val="0A0A0A"/>
+                </a:solidFill>
+              </a:rPr>
+              <a:t>•  Session 2 covers the daily loop, sandbox, skills, tools</a:t>
+            </a:r>
+          </a:p>
+          <a:p>
+            <a:pPr>
+              <a:spcAft>
+                <a:spcPts val="1000"/>
+              </a:spcAft>
+            </a:pPr>
+            <a:r>
+              <a:rPr sz="2200">
+                <a:solidFill>
+                  <a:srgbClr val="0A0A0A"/>
+                </a:solidFill>
+              </a:rPr>
+              <a:t>•  Keep the spine in mind: you check, you decide</a:t>
             </a:r>
           </a:p>
         </p:txBody>
@@ -7301,8 +7490,8 @@
         </p:blipFill>
         <p:spPr>
           <a:xfrm>
-            <a:off x="10607040" y="365760"/>
-            <a:ext cx="548640" cy="548640"/>
+            <a:off x="548640" y="457200"/>
+            <a:ext cx="731520" cy="731520"/>
           </a:xfrm>
           <a:prstGeom prst="rect">
             <a:avLst/>
@@ -7317,7 +7506,7 @@
         </p:nvSpPr>
         <p:spPr>
           <a:xfrm>
-            <a:off x="640080" y="457200"/>
+            <a:off x="640080" y="2926080"/>
             <a:ext cx="10972800" cy="1828800"/>
           </a:xfrm>
           <a:prstGeom prst="rect">
@@ -7331,112 +7520,14 @@
           </a:bodyPr>
           <a:lstStyle/>
           <a:p>
-            <a:pPr algn="l"/>
-            <a:r>
-              <a:rPr sz="3200" b="1">
-                <a:solidFill>
-                  <a:srgbClr val="0A0A0A"/>
-                </a:solidFill>
-              </a:rPr>
-              <a:t>The daily loop</a:t>
-            </a:r>
-          </a:p>
-        </p:txBody>
-      </p:sp>
-      <p:sp>
-        <p:nvSpPr>
-          <p:cNvPr id="4" name="TextBox 3"/>
-          <p:cNvSpPr txBox="1"/>
-          <p:nvPr/>
-        </p:nvSpPr>
-        <p:spPr>
-          <a:xfrm>
-            <a:off x="822960" y="1828800"/>
-            <a:ext cx="10515600" cy="4114800"/>
-          </a:xfrm>
-          <a:prstGeom prst="rect">
-            <a:avLst/>
-          </a:prstGeom>
-          <a:noFill/>
-        </p:spPr>
-        <p:txBody>
-          <a:bodyPr wrap="square">
-            <a:spAutoFit/>
-          </a:bodyPr>
-          <a:lstStyle/>
-          <a:p>
-            <a:pPr>
-              <a:spcAft>
-                <a:spcPts val="1000"/>
-              </a:spcAft>
-            </a:pPr>
-            <a:r>
-              <a:rPr sz="2200">
-                <a:solidFill>
-                  <a:srgbClr val="0A0A0A"/>
-                </a:solidFill>
-              </a:rPr>
-              <a:t>•  Talk it out → get a plan → build it → check it → save it</a:t>
-            </a:r>
-          </a:p>
-          <a:p>
-            <a:pPr>
-              <a:spcAft>
-                <a:spcPts val="1000"/>
-              </a:spcAft>
-            </a:pPr>
-            <a:r>
-              <a:rPr sz="2200">
-                <a:solidFill>
-                  <a:srgbClr val="0A0A0A"/>
-                </a:solidFill>
-              </a:rPr>
-              <a:t>•  Talk it out: describe the outcome, plain English</a:t>
-            </a:r>
-          </a:p>
-          <a:p>
-            <a:pPr>
-              <a:spcAft>
-                <a:spcPts val="1000"/>
-              </a:spcAft>
-            </a:pPr>
-            <a:r>
-              <a:rPr sz="2200">
-                <a:solidFill>
-                  <a:srgbClr val="0A0A0A"/>
-                </a:solidFill>
-              </a:rPr>
-              <a:t>•  Get a plan: what Claude will do, before any code</a:t>
-            </a:r>
-          </a:p>
-          <a:p>
-            <a:pPr>
-              <a:spcAft>
-                <a:spcPts val="1000"/>
-              </a:spcAft>
-            </a:pPr>
-            <a:r>
-              <a:rPr sz="2200">
-                <a:solidFill>
-                  <a:srgbClr val="0A0A0A"/>
-                </a:solidFill>
-              </a:rPr>
-              <a:t>•  Build it: only once you've approved the plan</a:t>
-            </a:r>
-          </a:p>
-          <a:p>
-            <a:pPr>
-              <a:spcAft>
-                <a:spcPts val="1000"/>
-              </a:spcAft>
-            </a:pPr>
-            <a:r>
-              <a:rPr sz="2200">
-                <a:solidFill>
-                  <a:srgbClr val="0A0A0A"/>
-                </a:solidFill>
-              </a:rPr>
-              <a:t>•  Check it: open the result yourself — don't take Claude's word</a:t>
+            <a:pPr algn="ctr"/>
+            <a:r>
+              <a:rPr sz="4000" b="1">
+                <a:solidFill>
+                  <a:srgbClr val="0A0A0A"/>
+                </a:solidFill>
+              </a:rPr>
+              <a:t>Session 2: Work With It</a:t>
             </a:r>
           </a:p>
         </p:txBody>
@@ -7520,7 +7611,7 @@
                   <a:srgbClr val="0A0A0A"/>
                 </a:solidFill>
               </a:rPr>
-              <a:t>Plan the disk-check script</a:t>
+              <a:t>The daily loop</a:t>
             </a:r>
           </a:p>
         </p:txBody>
@@ -7558,67 +7649,82 @@
                   <a:srgbClr val="0A0A0A"/>
                 </a:solidFill>
               </a:rPr>
-              <a:t>•  Talk it out: read servers, check free disk space, write a report</a:t>
-            </a:r>
-          </a:p>
-          <a:p>
-            <a:pPr>
-              <a:spcAft>
-                <a:spcPts val="1000"/>
-              </a:spcAft>
-            </a:pPr>
-            <a:r>
-              <a:rPr sz="2200">
-                <a:solidFill>
-                  <a:srgbClr val="0A0A0A"/>
-                </a:solidFill>
-              </a:rPr>
-              <a:t>•  Ask for a plan — explicitly say "don't write code yet"</a:t>
-            </a:r>
-          </a:p>
-          <a:p>
-            <a:pPr>
-              <a:spcAft>
-                <a:spcPts val="1000"/>
-              </a:spcAft>
-            </a:pPr>
-            <a:r>
-              <a:rPr sz="2200">
-                <a:solidFill>
-                  <a:srgbClr val="0A0A0A"/>
-                </a:solidFill>
-              </a:rPr>
-              <a:t>•  Compare it to the reference plan: goal, steps, Done-criteria</a:t>
-            </a:r>
-          </a:p>
-          <a:p>
-            <a:pPr>
-              <a:spcAft>
-                <a:spcPts val="1000"/>
-              </a:spcAft>
-            </a:pPr>
-            <a:r>
-              <a:rPr sz="2200">
-                <a:solidFill>
-                  <a:srgbClr val="0A0A0A"/>
-                </a:solidFill>
-              </a:rPr>
-              <a:t>•  Approve it, then let Claude build `disk_report.py`</a:t>
-            </a:r>
-          </a:p>
-          <a:p>
-            <a:pPr>
-              <a:spcAft>
-                <a:spcPts val="1000"/>
-              </a:spcAft>
-            </a:pPr>
-            <a:r>
-              <a:rPr sz="2200">
-                <a:solidFill>
-                  <a:srgbClr val="0A0A0A"/>
-                </a:solidFill>
-              </a:rPr>
-              <a:t>•  Check the result yourself: open `report.html`</a:t>
+              <a:t>•  Talk it out → get a plan → build it → check it → save it</a:t>
+            </a:r>
+          </a:p>
+          <a:p>
+            <a:pPr>
+              <a:spcAft>
+                <a:spcPts val="1000"/>
+              </a:spcAft>
+            </a:pPr>
+            <a:r>
+              <a:rPr sz="2200">
+                <a:solidFill>
+                  <a:srgbClr val="0A0A0A"/>
+                </a:solidFill>
+              </a:rPr>
+              <a:t>•  Talk it out: describe the outcome, plain English</a:t>
+            </a:r>
+          </a:p>
+          <a:p>
+            <a:pPr>
+              <a:spcAft>
+                <a:spcPts val="1000"/>
+              </a:spcAft>
+            </a:pPr>
+            <a:r>
+              <a:rPr sz="2200">
+                <a:solidFill>
+                  <a:srgbClr val="0A0A0A"/>
+                </a:solidFill>
+              </a:rPr>
+              <a:t>•  Get a plan: what Claude will do, before any code</a:t>
+            </a:r>
+          </a:p>
+          <a:p>
+            <a:pPr>
+              <a:spcAft>
+                <a:spcPts val="1000"/>
+              </a:spcAft>
+            </a:pPr>
+            <a:r>
+              <a:rPr sz="2200">
+                <a:solidFill>
+                  <a:srgbClr val="0A0A0A"/>
+                </a:solidFill>
+              </a:rPr>
+              <a:t>•  Build it: only once you've approved the plan</a:t>
+            </a:r>
+          </a:p>
+          <a:p>
+            <a:pPr>
+              <a:spcAft>
+                <a:spcPts val="1000"/>
+              </a:spcAft>
+            </a:pPr>
+            <a:r>
+              <a:rPr sz="2200">
+                <a:solidFill>
+                  <a:srgbClr val="0A0A0A"/>
+                </a:solidFill>
+              </a:rPr>
+              <a:t>•  Check it: open the result yourself — don't take Claude's word</a:t>
+            </a:r>
+          </a:p>
+          <a:p>
+            <a:pPr>
+              <a:spcAft>
+                <a:spcPts val="1000"/>
+              </a:spcAft>
+            </a:pPr>
+            <a:r>
+              <a:rPr sz="2200">
+                <a:solidFill>
+                  <a:srgbClr val="0A0A0A"/>
+                </a:solidFill>
+              </a:rPr>
+              <a:t>•  Save it: commit + open a PR so the work is on the record</a:t>
             </a:r>
           </a:p>
         </p:txBody>
@@ -7702,7 +7808,7 @@
                   <a:srgbClr val="0A0A0A"/>
                 </a:solidFill>
               </a:rPr>
-              <a:t>Safe sandbox + save to Azure DevOps</a:t>
+              <a:t>Plan the disk-check script</a:t>
             </a:r>
           </a:p>
         </p:txBody>
@@ -7740,67 +7846,67 @@
                   <a:srgbClr val="0A0A0A"/>
                 </a:solidFill>
               </a:rPr>
-              <a:t>•  Ask Claude to set up a safe sandbox for this work</a:t>
-            </a:r>
-          </a:p>
-          <a:p>
-            <a:pPr>
-              <a:spcAft>
-                <a:spcPts val="1000"/>
-              </a:spcAft>
-            </a:pPr>
-            <a:r>
-              <a:rPr sz="2200">
-                <a:solidFill>
-                  <a:srgbClr val="0A0A0A"/>
-                </a:solidFill>
-              </a:rPr>
-              <a:t>•  Confirm `disk_report.py` is built inside it</a:t>
-            </a:r>
-          </a:p>
-          <a:p>
-            <a:pPr>
-              <a:spcAft>
-                <a:spcPts val="1000"/>
-              </a:spcAft>
-            </a:pPr>
-            <a:r>
-              <a:rPr sz="2200">
-                <a:solidFill>
-                  <a:srgbClr val="0A0A0A"/>
-                </a:solidFill>
-              </a:rPr>
-              <a:t>•  Save it — Claude commits with a clear, short message</a:t>
-            </a:r>
-          </a:p>
-          <a:p>
-            <a:pPr>
-              <a:spcAft>
-                <a:spcPts val="1000"/>
-              </a:spcAft>
-            </a:pPr>
-            <a:r>
-              <a:rPr sz="2200">
-                <a:solidFill>
-                  <a:srgbClr val="0A0A0A"/>
-                </a:solidFill>
-              </a:rPr>
-              <a:t>•  Share it for review — open a pull request</a:t>
-            </a:r>
-          </a:p>
-          <a:p>
-            <a:pPr>
-              <a:spcAft>
-                <a:spcPts val="1000"/>
-              </a:spcAft>
-            </a:pPr>
-            <a:r>
-              <a:rPr sz="2200">
-                <a:solidFill>
-                  <a:srgbClr val="0A0A0A"/>
-                </a:solidFill>
-              </a:rPr>
-              <a:t>•  `az repos pr create` — or click Create Pull Request in VS Code</a:t>
+              <a:t>•  Talk it out: read servers, check free disk space, write a report</a:t>
+            </a:r>
+          </a:p>
+          <a:p>
+            <a:pPr>
+              <a:spcAft>
+                <a:spcPts val="1000"/>
+              </a:spcAft>
+            </a:pPr>
+            <a:r>
+              <a:rPr sz="2200">
+                <a:solidFill>
+                  <a:srgbClr val="0A0A0A"/>
+                </a:solidFill>
+              </a:rPr>
+              <a:t>•  Ask for a plan — explicitly say "don't write code yet"</a:t>
+            </a:r>
+          </a:p>
+          <a:p>
+            <a:pPr>
+              <a:spcAft>
+                <a:spcPts val="1000"/>
+              </a:spcAft>
+            </a:pPr>
+            <a:r>
+              <a:rPr sz="2200">
+                <a:solidFill>
+                  <a:srgbClr val="0A0A0A"/>
+                </a:solidFill>
+              </a:rPr>
+              <a:t>•  Compare it to the reference plan: goal, steps, Done-criteria</a:t>
+            </a:r>
+          </a:p>
+          <a:p>
+            <a:pPr>
+              <a:spcAft>
+                <a:spcPts val="1000"/>
+              </a:spcAft>
+            </a:pPr>
+            <a:r>
+              <a:rPr sz="2200">
+                <a:solidFill>
+                  <a:srgbClr val="0A0A0A"/>
+                </a:solidFill>
+              </a:rPr>
+              <a:t>•  Approve it, then let Claude build `disk_report.py`</a:t>
+            </a:r>
+          </a:p>
+          <a:p>
+            <a:pPr>
+              <a:spcAft>
+                <a:spcPts val="1000"/>
+              </a:spcAft>
+            </a:pPr>
+            <a:r>
+              <a:rPr sz="2200">
+                <a:solidFill>
+                  <a:srgbClr val="0A0A0A"/>
+                </a:solidFill>
+              </a:rPr>
+              <a:t>•  Check the result yourself: open `report.html`</a:t>
             </a:r>
           </a:p>
         </p:txBody>
@@ -7884,7 +7990,7 @@
                   <a:srgbClr val="0A0A0A"/>
                 </a:solidFill>
               </a:rPr>
-              <a:t>Checkpoint: a real PR in Azure DevOps</a:t>
+              <a:t>Safe sandbox + save to Azure DevOps</a:t>
             </a:r>
           </a:p>
         </p:txBody>
@@ -7922,37 +8028,67 @@
                   <a:srgbClr val="0A0A0A"/>
                 </a:solidFill>
               </a:rPr>
-              <a:t>•  Your work appears as a PR in Azure DevOps</a:t>
-            </a:r>
-          </a:p>
-          <a:p>
-            <a:pPr>
-              <a:spcAft>
-                <a:spcPts val="1000"/>
-              </a:spcAft>
-            </a:pPr>
-            <a:r>
-              <a:rPr sz="2200">
-                <a:solidFill>
-                  <a:srgbClr val="0A0A0A"/>
-                </a:solidFill>
-              </a:rPr>
-              <a:t>•  Confirm it with `az repos pr list`</a:t>
-            </a:r>
-          </a:p>
-          <a:p>
-            <a:pPr>
-              <a:spcAft>
-                <a:spcPts val="1000"/>
-              </a:spcAft>
-            </a:pPr>
-            <a:r>
-              <a:rPr sz="2200">
-                <a:solidFill>
-                  <a:srgbClr val="0A0A0A"/>
-                </a:solidFill>
-              </a:rPr>
-              <a:t>•  A reviewer can read and approve it before it goes live</a:t>
+              <a:t>•  Ask Claude to set up a safe sandbox for this work</a:t>
+            </a:r>
+          </a:p>
+          <a:p>
+            <a:pPr>
+              <a:spcAft>
+                <a:spcPts val="1000"/>
+              </a:spcAft>
+            </a:pPr>
+            <a:r>
+              <a:rPr sz="2200">
+                <a:solidFill>
+                  <a:srgbClr val="0A0A0A"/>
+                </a:solidFill>
+              </a:rPr>
+              <a:t>•  Confirm `disk_report.py` is built inside it</a:t>
+            </a:r>
+          </a:p>
+          <a:p>
+            <a:pPr>
+              <a:spcAft>
+                <a:spcPts val="1000"/>
+              </a:spcAft>
+            </a:pPr>
+            <a:r>
+              <a:rPr sz="2200">
+                <a:solidFill>
+                  <a:srgbClr val="0A0A0A"/>
+                </a:solidFill>
+              </a:rPr>
+              <a:t>•  Save it — Claude commits with a clear, short message</a:t>
+            </a:r>
+          </a:p>
+          <a:p>
+            <a:pPr>
+              <a:spcAft>
+                <a:spcPts val="1000"/>
+              </a:spcAft>
+            </a:pPr>
+            <a:r>
+              <a:rPr sz="2200">
+                <a:solidFill>
+                  <a:srgbClr val="0A0A0A"/>
+                </a:solidFill>
+              </a:rPr>
+              <a:t>•  Share it for review — open a pull request</a:t>
+            </a:r>
+          </a:p>
+          <a:p>
+            <a:pPr>
+              <a:spcAft>
+                <a:spcPts val="1000"/>
+              </a:spcAft>
+            </a:pPr>
+            <a:r>
+              <a:rPr sz="2200">
+                <a:solidFill>
+                  <a:srgbClr val="0A0A0A"/>
+                </a:solidFill>
+              </a:rPr>
+              <a:t>•  `az repos pr create` — or click Create Pull Request in VS Code</a:t>
             </a:r>
           </a:p>
         </p:txBody>
@@ -8158,7 +8294,7 @@
                   <a:srgbClr val="0A0A0A"/>
                 </a:solidFill>
               </a:rPr>
-              <a:t>Skills = saved runbook recipes</a:t>
+              <a:t>Checkpoint: a real PR in Azure DevOps</a:t>
             </a:r>
           </a:p>
         </p:txBody>
@@ -8196,67 +8332,37 @@
                   <a:srgbClr val="0A0A0A"/>
                 </a:solidFill>
               </a:rPr>
-              <a:t>•  A skill: the same steps, done the same way, every time</a:t>
-            </a:r>
-          </a:p>
-          <a:p>
-            <a:pPr>
-              <a:spcAft>
-                <a:spcPts val="1000"/>
-              </a:spcAft>
-            </a:pPr>
-            <a:r>
-              <a:rPr sz="2200">
-                <a:solidFill>
-                  <a:srgbClr val="0A0A0A"/>
-                </a:solidFill>
-              </a:rPr>
-              <a:t>•  Example: `add-server-to-health-check`</a:t>
-            </a:r>
-          </a:p>
-          <a:p>
-            <a:pPr>
-              <a:spcAft>
-                <a:spcPts val="1000"/>
-              </a:spcAft>
-            </a:pPr>
-            <a:r>
-              <a:rPr sz="2200">
-                <a:solidFill>
-                  <a:srgbClr val="0A0A0A"/>
-                </a:solidFill>
-              </a:rPr>
-              <a:t>•  Ask in plain English: "Add SVR-CONTOSO-05 to the health check"</a:t>
-            </a:r>
-          </a:p>
-          <a:p>
-            <a:pPr>
-              <a:spcAft>
-                <a:spcPts val="1000"/>
-              </a:spcAft>
-            </a:pPr>
-            <a:r>
-              <a:rPr sz="2200">
-                <a:solidFill>
-                  <a:srgbClr val="0A0A0A"/>
-                </a:solidFill>
-              </a:rPr>
-              <a:t>•  Claude follows the same 3 saved steps, in order</a:t>
-            </a:r>
-          </a:p>
-          <a:p>
-            <a:pPr>
-              <a:spcAft>
-                <a:spcPts val="1000"/>
-              </a:spcAft>
-            </a:pPr>
-            <a:r>
-              <a:rPr sz="2200">
-                <a:solidFill>
-                  <a:srgbClr val="0A0A0A"/>
-                </a:solidFill>
-              </a:rPr>
-              <a:t>•  Same result whether the primary or backup owner runs it</a:t>
+              <a:t>•  Your work appears as a PR in Azure DevOps</a:t>
+            </a:r>
+          </a:p>
+          <a:p>
+            <a:pPr>
+              <a:spcAft>
+                <a:spcPts val="1000"/>
+              </a:spcAft>
+            </a:pPr>
+            <a:r>
+              <a:rPr sz="2200">
+                <a:solidFill>
+                  <a:srgbClr val="0A0A0A"/>
+                </a:solidFill>
+              </a:rPr>
+              <a:t>•  Confirm it with `az repos pr list`</a:t>
+            </a:r>
+          </a:p>
+          <a:p>
+            <a:pPr>
+              <a:spcAft>
+                <a:spcPts val="1000"/>
+              </a:spcAft>
+            </a:pPr>
+            <a:r>
+              <a:rPr sz="2200">
+                <a:solidFill>
+                  <a:srgbClr val="0A0A0A"/>
+                </a:solidFill>
+              </a:rPr>
+              <a:t>•  A reviewer can read and approve it before it goes live</a:t>
             </a:r>
           </a:p>
         </p:txBody>
@@ -8340,7 +8446,7 @@
                   <a:srgbClr val="0A0A0A"/>
                 </a:solidFill>
               </a:rPr>
-              <a:t>Checkpoint: the skill ran its steps</a:t>
+              <a:t>Skills = saved runbook recipes</a:t>
             </a:r>
           </a:p>
         </p:txBody>
@@ -8378,37 +8484,67 @@
                   <a:srgbClr val="0A0A0A"/>
                 </a:solidFill>
               </a:rPr>
-              <a:t>•  The new server's row shows up in `report.html`</a:t>
-            </a:r>
-          </a:p>
-          <a:p>
-            <a:pPr>
-              <a:spcAft>
-                <a:spcPts val="1000"/>
-              </a:spcAft>
-            </a:pPr>
-            <a:r>
-              <a:rPr sz="2200">
-                <a:solidFill>
-                  <a:srgbClr val="0A0A0A"/>
-                </a:solidFill>
-              </a:rPr>
-              <a:t>•  Free-GB number and OK/LOW status included</a:t>
-            </a:r>
-          </a:p>
-          <a:p>
-            <a:pPr>
-              <a:spcAft>
-                <a:spcPts val="1000"/>
-              </a:spcAft>
-            </a:pPr>
-            <a:r>
-              <a:rPr sz="2200">
-                <a:solidFill>
-                  <a:srgbClr val="0A0A0A"/>
-                </a:solidFill>
-              </a:rPr>
-              <a:t>•  Same 3 steps, no re-explaining required</a:t>
+              <a:t>•  A skill: the same steps, done the same way, every time</a:t>
+            </a:r>
+          </a:p>
+          <a:p>
+            <a:pPr>
+              <a:spcAft>
+                <a:spcPts val="1000"/>
+              </a:spcAft>
+            </a:pPr>
+            <a:r>
+              <a:rPr sz="2200">
+                <a:solidFill>
+                  <a:srgbClr val="0A0A0A"/>
+                </a:solidFill>
+              </a:rPr>
+              <a:t>•  Example: `add-server-to-health-check`</a:t>
+            </a:r>
+          </a:p>
+          <a:p>
+            <a:pPr>
+              <a:spcAft>
+                <a:spcPts val="1000"/>
+              </a:spcAft>
+            </a:pPr>
+            <a:r>
+              <a:rPr sz="2200">
+                <a:solidFill>
+                  <a:srgbClr val="0A0A0A"/>
+                </a:solidFill>
+              </a:rPr>
+              <a:t>•  Ask in plain English: "Add SVR-CONTOSO-05 to the health check"</a:t>
+            </a:r>
+          </a:p>
+          <a:p>
+            <a:pPr>
+              <a:spcAft>
+                <a:spcPts val="1000"/>
+              </a:spcAft>
+            </a:pPr>
+            <a:r>
+              <a:rPr sz="2200">
+                <a:solidFill>
+                  <a:srgbClr val="0A0A0A"/>
+                </a:solidFill>
+              </a:rPr>
+              <a:t>•  Claude follows the same 3 saved steps, in order</a:t>
+            </a:r>
+          </a:p>
+          <a:p>
+            <a:pPr>
+              <a:spcAft>
+                <a:spcPts val="1000"/>
+              </a:spcAft>
+            </a:pPr>
+            <a:r>
+              <a:rPr sz="2200">
+                <a:solidFill>
+                  <a:srgbClr val="0A0A0A"/>
+                </a:solidFill>
+              </a:rPr>
+              <a:t>•  Same result whether the primary or backup owner runs it</a:t>
             </a:r>
           </a:p>
         </p:txBody>
@@ -8492,7 +8628,7 @@
                   <a:srgbClr val="0A0A0A"/>
                 </a:solidFill>
               </a:rPr>
-              <a:t>Connect your tools (MCP)</a:t>
+              <a:t>Checkpoint: the skill ran its steps</a:t>
             </a:r>
           </a:p>
         </p:txBody>
@@ -8530,67 +8666,37 @@
                   <a:srgbClr val="0A0A0A"/>
                 </a:solidFill>
               </a:rPr>
-              <a:t>•  MCP: a wired-up connection to a real tool</a:t>
-            </a:r>
-          </a:p>
-          <a:p>
-            <a:pPr>
-              <a:spcAft>
-                <a:spcPts val="1000"/>
-              </a:spcAft>
-            </a:pPr>
-            <a:r>
-              <a:rPr sz="2200">
-                <a:solidFill>
-                  <a:srgbClr val="0A0A0A"/>
-                </a:solidFill>
-              </a:rPr>
-              <a:t>•  For this stack: the Azure DevOps MCP server</a:t>
-            </a:r>
-          </a:p>
-          <a:p>
-            <a:pPr>
-              <a:spcAft>
-                <a:spcPts val="1000"/>
-              </a:spcAft>
-            </a:pPr>
-            <a:r>
-              <a:rPr sz="2200">
-                <a:solidFill>
-                  <a:srgbClr val="0A0A0A"/>
-                </a:solidFill>
-              </a:rPr>
-              <a:t>•  Confirm it: "Are you connected to Azure DevOps?"</a:t>
-            </a:r>
-          </a:p>
-          <a:p>
-            <a:pPr>
-              <a:spcAft>
-                <a:spcPts val="1000"/>
-              </a:spcAft>
-            </a:pPr>
-            <a:r>
-              <a:rPr sz="2200">
-                <a:solidFill>
-                  <a:srgbClr val="0A0A0A"/>
-                </a:solidFill>
-              </a:rPr>
-              <a:t>•  Ask: "What work items are assigned to me?"</a:t>
-            </a:r>
-          </a:p>
-          <a:p>
-            <a:pPr>
-              <a:spcAft>
-                <a:spcPts val="1000"/>
-              </a:spcAft>
-            </a:pPr>
-            <a:r>
-              <a:rPr sz="2200">
-                <a:solidFill>
-                  <a:srgbClr val="0A0A0A"/>
-                </a:solidFill>
-              </a:rPr>
-              <a:t>•  Claude answers from real, live data — not a guess</a:t>
+              <a:t>•  The new server's row shows up in `report.html`</a:t>
+            </a:r>
+          </a:p>
+          <a:p>
+            <a:pPr>
+              <a:spcAft>
+                <a:spcPts val="1000"/>
+              </a:spcAft>
+            </a:pPr>
+            <a:r>
+              <a:rPr sz="2200">
+                <a:solidFill>
+                  <a:srgbClr val="0A0A0A"/>
+                </a:solidFill>
+              </a:rPr>
+              <a:t>•  Free-GB number and OK/LOW status included</a:t>
+            </a:r>
+          </a:p>
+          <a:p>
+            <a:pPr>
+              <a:spcAft>
+                <a:spcPts val="1000"/>
+              </a:spcAft>
+            </a:pPr>
+            <a:r>
+              <a:rPr sz="2200">
+                <a:solidFill>
+                  <a:srgbClr val="0A0A0A"/>
+                </a:solidFill>
+              </a:rPr>
+              <a:t>•  Same 3 steps, no re-explaining required</a:t>
             </a:r>
           </a:p>
         </p:txBody>
@@ -8674,7 +8780,7 @@
                   <a:srgbClr val="0A0A0A"/>
                 </a:solidFill>
               </a:rPr>
-              <a:t>Checkpoint: Claude reads your real work items</a:t>
+              <a:t>Connect your tools (MCP)</a:t>
             </a:r>
           </a:p>
         </p:txBody>
@@ -8712,37 +8818,67 @@
                   <a:srgbClr val="0A0A0A"/>
                 </a:solidFill>
               </a:rPr>
-              <a:t>•  A plain-English question</a:t>
-            </a:r>
-          </a:p>
-          <a:p>
-            <a:pPr>
-              <a:spcAft>
-                <a:spcPts val="1000"/>
-              </a:spcAft>
-            </a:pPr>
-            <a:r>
-              <a:rPr sz="2200">
-                <a:solidFill>
-                  <a:srgbClr val="0A0A0A"/>
-                </a:solidFill>
-              </a:rPr>
-              <a:t>•  A real, current list from Azure Boards</a:t>
-            </a:r>
-          </a:p>
-          <a:p>
-            <a:pPr>
-              <a:spcAft>
-                <a:spcPts val="1000"/>
-              </a:spcAft>
-            </a:pPr>
-            <a:r>
-              <a:rPr sz="2200">
-                <a:solidFill>
-                  <a:srgbClr val="0A0A0A"/>
-                </a:solidFill>
-              </a:rPr>
-              <a:t>•  You never opened Azure DevOps yourself</a:t>
+              <a:t>•  MCP: a wired-up connection to a real tool</a:t>
+            </a:r>
+          </a:p>
+          <a:p>
+            <a:pPr>
+              <a:spcAft>
+                <a:spcPts val="1000"/>
+              </a:spcAft>
+            </a:pPr>
+            <a:r>
+              <a:rPr sz="2200">
+                <a:solidFill>
+                  <a:srgbClr val="0A0A0A"/>
+                </a:solidFill>
+              </a:rPr>
+              <a:t>•  For this stack: the Azure DevOps MCP server</a:t>
+            </a:r>
+          </a:p>
+          <a:p>
+            <a:pPr>
+              <a:spcAft>
+                <a:spcPts val="1000"/>
+              </a:spcAft>
+            </a:pPr>
+            <a:r>
+              <a:rPr sz="2200">
+                <a:solidFill>
+                  <a:srgbClr val="0A0A0A"/>
+                </a:solidFill>
+              </a:rPr>
+              <a:t>•  Confirm it: "Are you connected to Azure DevOps?"</a:t>
+            </a:r>
+          </a:p>
+          <a:p>
+            <a:pPr>
+              <a:spcAft>
+                <a:spcPts val="1000"/>
+              </a:spcAft>
+            </a:pPr>
+            <a:r>
+              <a:rPr sz="2200">
+                <a:solidFill>
+                  <a:srgbClr val="0A0A0A"/>
+                </a:solidFill>
+              </a:rPr>
+              <a:t>•  Ask: "What work items are assigned to me?"</a:t>
+            </a:r>
+          </a:p>
+          <a:p>
+            <a:pPr>
+              <a:spcAft>
+                <a:spcPts val="1000"/>
+              </a:spcAft>
+            </a:pPr>
+            <a:r>
+              <a:rPr sz="2200">
+                <a:solidFill>
+                  <a:srgbClr val="0A0A0A"/>
+                </a:solidFill>
+              </a:rPr>
+              <a:t>•  Claude answers from real, live data — not a guess</a:t>
             </a:r>
           </a:p>
         </p:txBody>
@@ -8826,7 +8962,7 @@
                   <a:srgbClr val="0A0A0A"/>
                 </a:solidFill>
               </a:rPr>
-              <a:t>Session 2 recap</a:t>
+              <a:t>Checkpoint: Claude reads your real work items</a:t>
             </a:r>
           </a:p>
         </p:txBody>
@@ -8864,52 +9000,37 @@
                   <a:srgbClr val="0A0A0A"/>
                 </a:solidFill>
               </a:rPr>
-              <a:t>•  All 5 pieces are now standing</a:t>
-            </a:r>
-          </a:p>
-          <a:p>
-            <a:pPr>
-              <a:spcAft>
-                <a:spcPts val="1000"/>
-              </a:spcAft>
-            </a:pPr>
-            <a:r>
-              <a:rPr sz="2200">
-                <a:solidFill>
-                  <a:srgbClr val="0A0A0A"/>
-                </a:solidFill>
-              </a:rPr>
-              <a:t>•  You ran the full loop: talk, plan, build, check, save</a:t>
-            </a:r>
-          </a:p>
-          <a:p>
-            <a:pPr>
-              <a:spcAft>
-                <a:spcPts val="1000"/>
-              </a:spcAft>
-            </a:pPr>
-            <a:r>
-              <a:rPr sz="2200">
-                <a:solidFill>
-                  <a:srgbClr val="0A0A0A"/>
-                </a:solidFill>
-              </a:rPr>
-              <a:t>•  Real output today: a PR, a skill run, a live tool connection</a:t>
-            </a:r>
-          </a:p>
-          <a:p>
-            <a:pPr>
-              <a:spcAft>
-                <a:spcPts val="1000"/>
-              </a:spcAft>
-            </a:pPr>
-            <a:r>
-              <a:rPr sz="2200">
-                <a:solidFill>
-                  <a:srgbClr val="0A0A0A"/>
-                </a:solidFill>
-              </a:rPr>
-              <a:t>•  Next: how this survives you being out</a:t>
+              <a:t>•  A plain-English question</a:t>
+            </a:r>
+          </a:p>
+          <a:p>
+            <a:pPr>
+              <a:spcAft>
+                <a:spcPts val="1000"/>
+              </a:spcAft>
+            </a:pPr>
+            <a:r>
+              <a:rPr sz="2200">
+                <a:solidFill>
+                  <a:srgbClr val="0A0A0A"/>
+                </a:solidFill>
+              </a:rPr>
+              <a:t>•  A real, current list from Azure Boards</a:t>
+            </a:r>
+          </a:p>
+          <a:p>
+            <a:pPr>
+              <a:spcAft>
+                <a:spcPts val="1000"/>
+              </a:spcAft>
+            </a:pPr>
+            <a:r>
+              <a:rPr sz="2200">
+                <a:solidFill>
+                  <a:srgbClr val="0A0A0A"/>
+                </a:solidFill>
+              </a:rPr>
+              <a:t>•  You never opened Azure DevOps yourself</a:t>
             </a:r>
           </a:p>
         </p:txBody>
@@ -8956,8 +9077,8 @@
         </p:blipFill>
         <p:spPr>
           <a:xfrm>
-            <a:off x="548640" y="457200"/>
-            <a:ext cx="731520" cy="731520"/>
+            <a:off x="10607040" y="365760"/>
+            <a:ext cx="548640" cy="548640"/>
           </a:xfrm>
           <a:prstGeom prst="rect">
             <a:avLst/>
@@ -8972,7 +9093,7 @@
         </p:nvSpPr>
         <p:spPr>
           <a:xfrm>
-            <a:off x="640080" y="2926080"/>
+            <a:off x="640080" y="457200"/>
             <a:ext cx="10972800" cy="1828800"/>
           </a:xfrm>
           <a:prstGeom prst="rect">
@@ -8986,14 +9107,97 @@
           </a:bodyPr>
           <a:lstStyle/>
           <a:p>
-            <a:pPr algn="ctr"/>
-            <a:r>
-              <a:rPr sz="4000" b="1">
-                <a:solidFill>
-                  <a:srgbClr val="0A0A0A"/>
-                </a:solidFill>
-              </a:rPr>
-              <a:t>Continuity &amp; Governance</a:t>
+            <a:pPr algn="l"/>
+            <a:r>
+              <a:rPr sz="3200" b="1">
+                <a:solidFill>
+                  <a:srgbClr val="0A0A0A"/>
+                </a:solidFill>
+              </a:rPr>
+              <a:t>Session 2 recap</a:t>
+            </a:r>
+          </a:p>
+        </p:txBody>
+      </p:sp>
+      <p:sp>
+        <p:nvSpPr>
+          <p:cNvPr id="4" name="TextBox 3"/>
+          <p:cNvSpPr txBox="1"/>
+          <p:nvPr/>
+        </p:nvSpPr>
+        <p:spPr>
+          <a:xfrm>
+            <a:off x="822960" y="1828800"/>
+            <a:ext cx="10515600" cy="4114800"/>
+          </a:xfrm>
+          <a:prstGeom prst="rect">
+            <a:avLst/>
+          </a:prstGeom>
+          <a:noFill/>
+        </p:spPr>
+        <p:txBody>
+          <a:bodyPr wrap="square">
+            <a:spAutoFit/>
+          </a:bodyPr>
+          <a:lstStyle/>
+          <a:p>
+            <a:pPr>
+              <a:spcAft>
+                <a:spcPts val="1000"/>
+              </a:spcAft>
+            </a:pPr>
+            <a:r>
+              <a:rPr sz="2200">
+                <a:solidFill>
+                  <a:srgbClr val="0A0A0A"/>
+                </a:solidFill>
+              </a:rPr>
+              <a:t>•  All 5 pieces are now standing</a:t>
+            </a:r>
+          </a:p>
+          <a:p>
+            <a:pPr>
+              <a:spcAft>
+                <a:spcPts val="1000"/>
+              </a:spcAft>
+            </a:pPr>
+            <a:r>
+              <a:rPr sz="2200">
+                <a:solidFill>
+                  <a:srgbClr val="0A0A0A"/>
+                </a:solidFill>
+              </a:rPr>
+              <a:t>•  You ran the full loop: talk, plan, build, check, save</a:t>
+            </a:r>
+          </a:p>
+          <a:p>
+            <a:pPr>
+              <a:spcAft>
+                <a:spcPts val="1000"/>
+              </a:spcAft>
+            </a:pPr>
+            <a:r>
+              <a:rPr sz="2200">
+                <a:solidFill>
+                  <a:srgbClr val="0A0A0A"/>
+                </a:solidFill>
+              </a:rPr>
+              <a:t>•  Real output today: a PR, a skill run, a live tool connection</a:t>
+            </a:r>
+          </a:p>
+          <a:p>
+            <a:pPr>
+              <a:spcAft>
+                <a:spcPts val="1000"/>
+              </a:spcAft>
+            </a:pPr>
+            <a:r>
+              <a:rPr sz="2200">
+                <a:solidFill>
+                  <a:srgbClr val="0A0A0A"/>
+                </a:solidFill>
+              </a:rPr>
+              <a:t>•  Next: how this survives you being out</a:t>
             </a:r>
           </a:p>
         </p:txBody>
@@ -9040,8 +9244,8 @@
         </p:blipFill>
         <p:spPr>
           <a:xfrm>
-            <a:off x="10607040" y="365760"/>
-            <a:ext cx="548640" cy="548640"/>
+            <a:off x="548640" y="457200"/>
+            <a:ext cx="731520" cy="731520"/>
           </a:xfrm>
           <a:prstGeom prst="rect">
             <a:avLst/>
@@ -9056,7 +9260,7 @@
         </p:nvSpPr>
         <p:spPr>
           <a:xfrm>
-            <a:off x="640080" y="457200"/>
+            <a:off x="640080" y="2926080"/>
             <a:ext cx="10972800" cy="1828800"/>
           </a:xfrm>
           <a:prstGeom prst="rect">
@@ -9070,97 +9274,14 @@
           </a:bodyPr>
           <a:lstStyle/>
           <a:p>
-            <a:pPr algn="l"/>
-            <a:r>
-              <a:rPr sz="3200" b="1">
-                <a:solidFill>
-                  <a:srgbClr val="0A0A0A"/>
-                </a:solidFill>
-              </a:rPr>
-              <a:t>The bus-factor problem</a:t>
-            </a:r>
-          </a:p>
-        </p:txBody>
-      </p:sp>
-      <p:sp>
-        <p:nvSpPr>
-          <p:cNvPr id="4" name="TextBox 3"/>
-          <p:cNvSpPr txBox="1"/>
-          <p:nvPr/>
-        </p:nvSpPr>
-        <p:spPr>
-          <a:xfrm>
-            <a:off x="822960" y="1828800"/>
-            <a:ext cx="10515600" cy="4114800"/>
-          </a:xfrm>
-          <a:prstGeom prst="rect">
-            <a:avLst/>
-          </a:prstGeom>
-          <a:noFill/>
-        </p:spPr>
-        <p:txBody>
-          <a:bodyPr wrap="square">
-            <a:spAutoFit/>
-          </a:bodyPr>
-          <a:lstStyle/>
-          <a:p>
-            <a:pPr>
-              <a:spcAft>
-                <a:spcPts val="1000"/>
-              </a:spcAft>
-            </a:pPr>
-            <a:r>
-              <a:rPr sz="2200">
-                <a:solidFill>
-                  <a:srgbClr val="0A0A0A"/>
-                </a:solidFill>
-              </a:rPr>
-              <a:t>•  Bus factor: how many people leaving stalls the work?</a:t>
-            </a:r>
-          </a:p>
-          <a:p>
-            <a:pPr>
-              <a:spcAft>
-                <a:spcPts val="1000"/>
-              </a:spcAft>
-            </a:pPr>
-            <a:r>
-              <a:rPr sz="2200">
-                <a:solidFill>
-                  <a:srgbClr val="0A0A0A"/>
-                </a:solidFill>
-              </a:rPr>
-              <a:t>•  If the answer is one, that person is the whole system</a:t>
-            </a:r>
-          </a:p>
-          <a:p>
-            <a:pPr>
-              <a:spcAft>
-                <a:spcPts val="1000"/>
-              </a:spcAft>
-            </a:pPr>
-            <a:r>
-              <a:rPr sz="2200">
-                <a:solidFill>
-                  <a:srgbClr val="0A0A0A"/>
-                </a:solidFill>
-              </a:rPr>
-              <a:t>•  The normal risk with internally-built tools, Claude or not</a:t>
-            </a:r>
-          </a:p>
-          <a:p>
-            <a:pPr>
-              <a:spcAft>
-                <a:spcPts val="1000"/>
-              </a:spcAft>
-            </a:pPr>
-            <a:r>
-              <a:rPr sz="2200">
-                <a:solidFill>
-                  <a:srgbClr val="0A0A0A"/>
-                </a:solidFill>
-              </a:rPr>
-              <a:t>•  The risk isn't the script — it's what only lives in one head</a:t>
+            <a:pPr algn="ctr"/>
+            <a:r>
+              <a:rPr sz="4000" b="1">
+                <a:solidFill>
+                  <a:srgbClr val="0A0A0A"/>
+                </a:solidFill>
+              </a:rPr>
+              <a:t>Continuity &amp; Governance</a:t>
             </a:r>
           </a:p>
         </p:txBody>
@@ -9244,7 +9365,7 @@
                   <a:srgbClr val="0A0A0A"/>
                 </a:solidFill>
               </a:rPr>
-              <a:t>How the method answers it</a:t>
+              <a:t>The bus-factor problem</a:t>
             </a:r>
           </a:p>
         </p:txBody>
@@ -9282,82 +9403,52 @@
                   <a:srgbClr val="0A0A0A"/>
                 </a:solidFill>
               </a:rPr>
-              <a:t>•  Bus factor → knowledge lives in the repo, not a head</a:t>
-            </a:r>
-          </a:p>
-          <a:p>
-            <a:pPr>
-              <a:spcAft>
-                <a:spcPts val="1000"/>
-              </a:spcAft>
-            </a:pPr>
-            <a:r>
-              <a:rPr sz="2200">
-                <a:solidFill>
-                  <a:srgbClr val="0A0A0A"/>
-                </a:solidFill>
-              </a:rPr>
-              <a:t>•  Backup owner → same steps work, no coding background needed</a:t>
-            </a:r>
-          </a:p>
-          <a:p>
-            <a:pPr>
-              <a:spcAft>
-                <a:spcPts val="1000"/>
-              </a:spcAft>
-            </a:pPr>
-            <a:r>
-              <a:rPr sz="2200">
-                <a:solidFill>
-                  <a:srgbClr val="0A0A0A"/>
-                </a:solidFill>
-              </a:rPr>
-              <a:t>•  Runbook stays current → the wiki + skills ARE the runbook</a:t>
-            </a:r>
-          </a:p>
-          <a:p>
-            <a:pPr>
-              <a:spcAft>
-                <a:spcPts val="1000"/>
-              </a:spcAft>
-            </a:pPr>
-            <a:r>
-              <a:rPr sz="2200">
-                <a:solidFill>
-                  <a:srgbClr val="0A0A0A"/>
-                </a:solidFill>
-              </a:rPr>
-              <a:t>•  Deploy unaided → Azure DevOps + skills/PowerShell + a proof test</a:t>
-            </a:r>
-          </a:p>
-          <a:p>
-            <a:pPr>
-              <a:spcAft>
-                <a:spcPts val="1000"/>
-              </a:spcAft>
-            </a:pPr>
-            <a:r>
-              <a:rPr sz="2200">
-                <a:solidFill>
-                  <a:srgbClr val="0A0A0A"/>
-                </a:solidFill>
-              </a:rPr>
-              <a:t>•  Decisions on record → specs, plans, PR descriptions</a:t>
-            </a:r>
-          </a:p>
-          <a:p>
-            <a:pPr>
-              <a:spcAft>
-                <a:spcPts val="1000"/>
-              </a:spcAft>
-            </a:pPr>
-            <a:r>
-              <a:rPr sz="2200">
-                <a:solidFill>
-                  <a:srgbClr val="0A0A0A"/>
-                </a:solidFill>
-              </a:rPr>
-              <a:t>•  Secrets stay safe → `.gitignore` + scan + read-only keys + a rule</a:t>
+              <a:t>•  Bus factor: how many people leaving stalls the work?</a:t>
+            </a:r>
+          </a:p>
+          <a:p>
+            <a:pPr>
+              <a:spcAft>
+                <a:spcPts val="1000"/>
+              </a:spcAft>
+            </a:pPr>
+            <a:r>
+              <a:rPr sz="2200">
+                <a:solidFill>
+                  <a:srgbClr val="0A0A0A"/>
+                </a:solidFill>
+              </a:rPr>
+              <a:t>•  If the answer is one, that person is the whole system</a:t>
+            </a:r>
+          </a:p>
+          <a:p>
+            <a:pPr>
+              <a:spcAft>
+                <a:spcPts val="1000"/>
+              </a:spcAft>
+            </a:pPr>
+            <a:r>
+              <a:rPr sz="2200">
+                <a:solidFill>
+                  <a:srgbClr val="0A0A0A"/>
+                </a:solidFill>
+              </a:rPr>
+              <a:t>•  The normal risk with internally-built tools, Claude or not</a:t>
+            </a:r>
+          </a:p>
+          <a:p>
+            <a:pPr>
+              <a:spcAft>
+                <a:spcPts val="1000"/>
+              </a:spcAft>
+            </a:pPr>
+            <a:r>
+              <a:rPr sz="2200">
+                <a:solidFill>
+                  <a:srgbClr val="0A0A0A"/>
+                </a:solidFill>
+              </a:rPr>
+              <a:t>•  The risk isn't the script — it's what only lives in one head</a:t>
             </a:r>
           </a:p>
         </p:txBody>
@@ -9441,7 +9532,7 @@
                   <a:srgbClr val="0A0A0A"/>
                 </a:solidFill>
               </a:rPr>
-              <a:t>The proof: deploy from source, unaided</a:t>
+              <a:t>How the method answers it</a:t>
             </a:r>
           </a:p>
         </p:txBody>
@@ -9479,67 +9570,82 @@
                   <a:srgbClr val="0A0A0A"/>
                 </a:solidFill>
               </a:rPr>
-              <a:t>•  Deploy from source to a clean Windows box, runbook only</a:t>
-            </a:r>
-          </a:p>
-          <a:p>
-            <a:pPr>
-              <a:spcAft>
-                <a:spcPts val="1000"/>
-              </a:spcAft>
-            </a:pPr>
-            <a:r>
-              <a:rPr sz="2200">
-                <a:solidFill>
-                  <a:srgbClr val="0A0A0A"/>
-                </a:solidFill>
-              </a:rPr>
-              <a:t>•  No verbal help from whoever built it</a:t>
-            </a:r>
-          </a:p>
-          <a:p>
-            <a:pPr>
-              <a:spcAft>
-                <a:spcPts val="1000"/>
-              </a:spcAft>
-            </a:pPr>
-            <a:r>
-              <a:rPr sz="2200">
-                <a:solidFill>
-                  <a:srgbClr val="0A0A0A"/>
-                </a:solidFill>
-              </a:rPr>
-              <a:t>•  All the way through → the runbook is sufficient</a:t>
-            </a:r>
-          </a:p>
-          <a:p>
-            <a:pPr>
-              <a:spcAft>
-                <a:spcPts val="1000"/>
-              </a:spcAft>
-            </a:pPr>
-            <a:r>
-              <a:rPr sz="2200">
-                <a:solidFill>
-                  <a:srgbClr val="0A0A0A"/>
-                </a:solidFill>
-              </a:rPr>
-              <a:t>•  They get stuck → a gap found safely, on a test machine</a:t>
-            </a:r>
-          </a:p>
-          <a:p>
-            <a:pPr>
-              <a:spcAft>
-                <a:spcPts val="1000"/>
-              </a:spcAft>
-            </a:pPr>
-            <a:r>
-              <a:rPr sz="2200">
-                <a:solidFill>
-                  <a:srgbClr val="0A0A0A"/>
-                </a:solidFill>
-              </a:rPr>
-              <a:t>•  Run it whenever the runbook changes, and before any handover</a:t>
+              <a:t>•  Bus factor → knowledge lives in the repo, not a head</a:t>
+            </a:r>
+          </a:p>
+          <a:p>
+            <a:pPr>
+              <a:spcAft>
+                <a:spcPts val="1000"/>
+              </a:spcAft>
+            </a:pPr>
+            <a:r>
+              <a:rPr sz="2200">
+                <a:solidFill>
+                  <a:srgbClr val="0A0A0A"/>
+                </a:solidFill>
+              </a:rPr>
+              <a:t>•  Backup owner → same steps work, no coding background needed</a:t>
+            </a:r>
+          </a:p>
+          <a:p>
+            <a:pPr>
+              <a:spcAft>
+                <a:spcPts val="1000"/>
+              </a:spcAft>
+            </a:pPr>
+            <a:r>
+              <a:rPr sz="2200">
+                <a:solidFill>
+                  <a:srgbClr val="0A0A0A"/>
+                </a:solidFill>
+              </a:rPr>
+              <a:t>•  Runbook stays current → the wiki + skills ARE the runbook</a:t>
+            </a:r>
+          </a:p>
+          <a:p>
+            <a:pPr>
+              <a:spcAft>
+                <a:spcPts val="1000"/>
+              </a:spcAft>
+            </a:pPr>
+            <a:r>
+              <a:rPr sz="2200">
+                <a:solidFill>
+                  <a:srgbClr val="0A0A0A"/>
+                </a:solidFill>
+              </a:rPr>
+              <a:t>•  Deploy unaided → Azure DevOps + skills/PowerShell + a proof test</a:t>
+            </a:r>
+          </a:p>
+          <a:p>
+            <a:pPr>
+              <a:spcAft>
+                <a:spcPts val="1000"/>
+              </a:spcAft>
+            </a:pPr>
+            <a:r>
+              <a:rPr sz="2200">
+                <a:solidFill>
+                  <a:srgbClr val="0A0A0A"/>
+                </a:solidFill>
+              </a:rPr>
+              <a:t>•  Decisions on record → specs, plans, PR descriptions</a:t>
+            </a:r>
+          </a:p>
+          <a:p>
+            <a:pPr>
+              <a:spcAft>
+                <a:spcPts val="1000"/>
+              </a:spcAft>
+            </a:pPr>
+            <a:r>
+              <a:rPr sz="2200">
+                <a:solidFill>
+                  <a:srgbClr val="0A0A0A"/>
+                </a:solidFill>
+              </a:rPr>
+              <a:t>•  Secrets stay safe → `.gitignore` + scan + read-only keys + a rule</a:t>
             </a:r>
           </a:p>
         </p:txBody>
@@ -9623,7 +9729,7 @@
                   <a:srgbClr val="0A0A0A"/>
                 </a:solidFill>
               </a:rPr>
-              <a:t>Secrets &amp; safety, in one place</a:t>
+              <a:t>The proof: deploy from source, unaided</a:t>
             </a:r>
           </a:p>
         </p:txBody>
@@ -9661,67 +9767,67 @@
                   <a:srgbClr val="0A0A0A"/>
                 </a:solidFill>
               </a:rPr>
-              <a:t>•  Rule: secrets never live in a tracked file</a:t>
-            </a:r>
-          </a:p>
-          <a:p>
-            <a:pPr>
-              <a:spcAft>
-                <a:spcPts val="1000"/>
-              </a:spcAft>
-            </a:pPr>
-            <a:r>
-              <a:rPr sz="2200">
-                <a:solidFill>
-                  <a:srgbClr val="0A0A0A"/>
-                </a:solidFill>
-              </a:rPr>
-              <a:t>•  Repo: `.gitignore` + a pre-commit secret-scan hook</a:t>
-            </a:r>
-          </a:p>
-          <a:p>
-            <a:pPr>
-              <a:spcAft>
-                <a:spcPts val="1000"/>
-              </a:spcAft>
-            </a:pPr>
-            <a:r>
-              <a:rPr sz="2200">
-                <a:solidFill>
-                  <a:srgbClr val="0A0A0A"/>
-                </a:solidFill>
-              </a:rPr>
-              <a:t>•  `CLAUDE.md`: a rule to never write a key to tracked files</a:t>
-            </a:r>
-          </a:p>
-          <a:p>
-            <a:pPr>
-              <a:spcAft>
-                <a:spcPts val="1000"/>
-              </a:spcAft>
-            </a:pPr>
-            <a:r>
-              <a:rPr sz="2200">
-                <a:solidFill>
-                  <a:srgbClr val="0A0A0A"/>
-                </a:solidFill>
-              </a:rPr>
-              <a:t>•  Tool connections: read-only wherever possible</a:t>
-            </a:r>
-          </a:p>
-          <a:p>
-            <a:pPr>
-              <a:spcAft>
-                <a:spcPts val="1000"/>
-              </a:spcAft>
-            </a:pPr>
-            <a:r>
-              <a:rPr sz="2200">
-                <a:solidFill>
-                  <a:srgbClr val="0A0A0A"/>
-                </a:solidFill>
-              </a:rPr>
-              <a:t>•  Runtime: Windows Credential Manager / DPAPI</a:t>
+              <a:t>•  Deploy from source to a clean Windows box, runbook only</a:t>
+            </a:r>
+          </a:p>
+          <a:p>
+            <a:pPr>
+              <a:spcAft>
+                <a:spcPts val="1000"/>
+              </a:spcAft>
+            </a:pPr>
+            <a:r>
+              <a:rPr sz="2200">
+                <a:solidFill>
+                  <a:srgbClr val="0A0A0A"/>
+                </a:solidFill>
+              </a:rPr>
+              <a:t>•  No verbal help from whoever built it</a:t>
+            </a:r>
+          </a:p>
+          <a:p>
+            <a:pPr>
+              <a:spcAft>
+                <a:spcPts val="1000"/>
+              </a:spcAft>
+            </a:pPr>
+            <a:r>
+              <a:rPr sz="2200">
+                <a:solidFill>
+                  <a:srgbClr val="0A0A0A"/>
+                </a:solidFill>
+              </a:rPr>
+              <a:t>•  All the way through → the runbook is sufficient</a:t>
+            </a:r>
+          </a:p>
+          <a:p>
+            <a:pPr>
+              <a:spcAft>
+                <a:spcPts val="1000"/>
+              </a:spcAft>
+            </a:pPr>
+            <a:r>
+              <a:rPr sz="2200">
+                <a:solidFill>
+                  <a:srgbClr val="0A0A0A"/>
+                </a:solidFill>
+              </a:rPr>
+              <a:t>•  They get stuck → a gap found safely, on a test machine</a:t>
+            </a:r>
+          </a:p>
+          <a:p>
+            <a:pPr>
+              <a:spcAft>
+                <a:spcPts val="1000"/>
+              </a:spcAft>
+            </a:pPr>
+            <a:r>
+              <a:rPr sz="2200">
+                <a:solidFill>
+                  <a:srgbClr val="0A0A0A"/>
+                </a:solidFill>
+              </a:rPr>
+              <a:t>•  Run it whenever the runbook changes, and before any handover</a:t>
             </a:r>
           </a:p>
         </p:txBody>
@@ -10002,7 +10108,7 @@
                   <a:srgbClr val="0A0A0A"/>
                 </a:solidFill>
               </a:rPr>
-              <a:t>The one-slide governance summary</a:t>
+              <a:t>Secrets &amp; safety, in one place</a:t>
             </a:r>
           </a:p>
         </p:txBody>
@@ -10040,67 +10146,67 @@
                   <a:srgbClr val="0A0A0A"/>
                 </a:solidFill>
               </a:rPr>
-              <a:t>•  A documented, repeatable method — not one engineer's head</a:t>
-            </a:r>
-          </a:p>
-          <a:p>
-            <a:pPr>
-              <a:spcAft>
-                <a:spcPts val="1000"/>
-              </a:spcAft>
-            </a:pPr>
-            <a:r>
-              <a:rPr sz="2200">
-                <a:solidFill>
-                  <a:srgbClr val="0A0A0A"/>
-                </a:solidFill>
-              </a:rPr>
-              <a:t>•  A named backup owner can run the same method</a:t>
-            </a:r>
-          </a:p>
-          <a:p>
-            <a:pPr>
-              <a:spcAft>
-                <a:spcPts val="1000"/>
-              </a:spcAft>
-            </a:pPr>
-            <a:r>
-              <a:rPr sz="2200">
-                <a:solidFill>
-                  <a:srgbClr val="0A0A0A"/>
-                </a:solidFill>
-              </a:rPr>
-              <a:t>•  The runbook is current by construction — the same doc used daily</a:t>
-            </a:r>
-          </a:p>
-          <a:p>
-            <a:pPr>
-              <a:spcAft>
-                <a:spcPts val="1000"/>
-              </a:spcAft>
-            </a:pPr>
-            <a:r>
-              <a:rPr sz="2200">
-                <a:solidFill>
-                  <a:srgbClr val="0A0A0A"/>
-                </a:solidFill>
-              </a:rPr>
-              <a:t>•  Tested, not assumed: deployed from source on a clean machine</a:t>
-            </a:r>
-          </a:p>
-          <a:p>
-            <a:pPr>
-              <a:spcAft>
-                <a:spcPts val="1000"/>
-              </a:spcAft>
-            </a:pPr>
-            <a:r>
-              <a:rPr sz="2200">
-                <a:solidFill>
-                  <a:srgbClr val="0A0A0A"/>
-                </a:solidFill>
-              </a:rPr>
-              <a:t>•  Secrets stay out of tracked source, always</a:t>
+              <a:t>•  Rule: secrets never live in a tracked file</a:t>
+            </a:r>
+          </a:p>
+          <a:p>
+            <a:pPr>
+              <a:spcAft>
+                <a:spcPts val="1000"/>
+              </a:spcAft>
+            </a:pPr>
+            <a:r>
+              <a:rPr sz="2200">
+                <a:solidFill>
+                  <a:srgbClr val="0A0A0A"/>
+                </a:solidFill>
+              </a:rPr>
+              <a:t>•  Repo: `.gitignore` + a pre-commit secret-scan hook</a:t>
+            </a:r>
+          </a:p>
+          <a:p>
+            <a:pPr>
+              <a:spcAft>
+                <a:spcPts val="1000"/>
+              </a:spcAft>
+            </a:pPr>
+            <a:r>
+              <a:rPr sz="2200">
+                <a:solidFill>
+                  <a:srgbClr val="0A0A0A"/>
+                </a:solidFill>
+              </a:rPr>
+              <a:t>•  `CLAUDE.md`: a rule to never write a key to tracked files</a:t>
+            </a:r>
+          </a:p>
+          <a:p>
+            <a:pPr>
+              <a:spcAft>
+                <a:spcPts val="1000"/>
+              </a:spcAft>
+            </a:pPr>
+            <a:r>
+              <a:rPr sz="2200">
+                <a:solidFill>
+                  <a:srgbClr val="0A0A0A"/>
+                </a:solidFill>
+              </a:rPr>
+              <a:t>•  Tool connections: read-only wherever possible</a:t>
+            </a:r>
+          </a:p>
+          <a:p>
+            <a:pPr>
+              <a:spcAft>
+                <a:spcPts val="1000"/>
+              </a:spcAft>
+            </a:pPr>
+            <a:r>
+              <a:rPr sz="2200">
+                <a:solidFill>
+                  <a:srgbClr val="0A0A0A"/>
+                </a:solidFill>
+              </a:rPr>
+              <a:t>•  Runtime: Windows Credential Manager / DPAPI</a:t>
             </a:r>
           </a:p>
         </p:txBody>
@@ -10184,7 +10290,7 @@
                   <a:srgbClr val="0A0A0A"/>
                 </a:solidFill>
               </a:rPr>
-              <a:t>Your first week cheat sheet</a:t>
+              <a:t>The one-slide governance summary</a:t>
             </a:r>
           </a:p>
         </p:txBody>
@@ -10222,52 +10328,67 @@
                   <a:srgbClr val="0A0A0A"/>
                 </a:solidFill>
               </a:rPr>
-              <a:t>•  The daily loop, in five words: talk, plan, build, check, save</a:t>
-            </a:r>
-          </a:p>
-          <a:p>
-            <a:pPr>
-              <a:spcAft>
-                <a:spcPts val="1000"/>
-              </a:spcAft>
-            </a:pPr>
-            <a:r>
-              <a:rPr sz="2200">
-                <a:solidFill>
-                  <a:srgbClr val="0A0A0A"/>
-                </a:solidFill>
-              </a:rPr>
-              <a:t>•  Three commands you'll actually type — or ask Claude to</a:t>
-            </a:r>
-          </a:p>
-          <a:p>
-            <a:pPr>
-              <a:spcAft>
-                <a:spcPts val="1000"/>
-              </a:spcAft>
-            </a:pPr>
-            <a:r>
-              <a:rPr sz="2200">
-                <a:solidFill>
-                  <a:srgbClr val="0A0A0A"/>
-                </a:solidFill>
-              </a:rPr>
-              <a:t>•  Where things live: your memory folder, your skills folder</a:t>
-            </a:r>
-          </a:p>
-          <a:p>
-            <a:pPr>
-              <a:spcAft>
-                <a:spcPts val="1000"/>
-              </a:spcAft>
-            </a:pPr>
-            <a:r>
-              <a:rPr sz="2200">
-                <a:solidFill>
-                  <a:srgbClr val="0A0A0A"/>
-                </a:solidFill>
-              </a:rPr>
-              <a:t>•  When stuck, ask Claude — five questions that unstick you</a:t>
+              <a:t>•  A documented, repeatable method — not one engineer's head</a:t>
+            </a:r>
+          </a:p>
+          <a:p>
+            <a:pPr>
+              <a:spcAft>
+                <a:spcPts val="1000"/>
+              </a:spcAft>
+            </a:pPr>
+            <a:r>
+              <a:rPr sz="2200">
+                <a:solidFill>
+                  <a:srgbClr val="0A0A0A"/>
+                </a:solidFill>
+              </a:rPr>
+              <a:t>•  A named backup owner can run the same method</a:t>
+            </a:r>
+          </a:p>
+          <a:p>
+            <a:pPr>
+              <a:spcAft>
+                <a:spcPts val="1000"/>
+              </a:spcAft>
+            </a:pPr>
+            <a:r>
+              <a:rPr sz="2200">
+                <a:solidFill>
+                  <a:srgbClr val="0A0A0A"/>
+                </a:solidFill>
+              </a:rPr>
+              <a:t>•  The runbook is current by construction — the same doc used daily</a:t>
+            </a:r>
+          </a:p>
+          <a:p>
+            <a:pPr>
+              <a:spcAft>
+                <a:spcPts val="1000"/>
+              </a:spcAft>
+            </a:pPr>
+            <a:r>
+              <a:rPr sz="2200">
+                <a:solidFill>
+                  <a:srgbClr val="0A0A0A"/>
+                </a:solidFill>
+              </a:rPr>
+              <a:t>•  Tested, not assumed: deployed from source on a clean machine</a:t>
+            </a:r>
+          </a:p>
+          <a:p>
+            <a:pPr>
+              <a:spcAft>
+                <a:spcPts val="1000"/>
+              </a:spcAft>
+            </a:pPr>
+            <a:r>
+              <a:rPr sz="2200">
+                <a:solidFill>
+                  <a:srgbClr val="0A0A0A"/>
+                </a:solidFill>
+              </a:rPr>
+              <a:t>•  Secrets stay out of tracked source, always</a:t>
             </a:r>
           </a:p>
         </p:txBody>
@@ -10351,7 +10472,7 @@
                   <a:srgbClr val="0A0A0A"/>
                 </a:solidFill>
               </a:rPr>
-              <a:t>Where to get help / what's next</a:t>
+              <a:t>Your first week cheat sheet</a:t>
             </a:r>
           </a:p>
         </p:txBody>
@@ -10389,52 +10510,52 @@
                   <a:srgbClr val="0A0A0A"/>
                 </a:solidFill>
               </a:rPr>
-              <a:t>•  Full glossary + full command cheat-sheet: always in this kit</a:t>
-            </a:r>
-          </a:p>
-          <a:p>
-            <a:pPr>
-              <a:spcAft>
-                <a:spcPts val="1000"/>
-              </a:spcAft>
-            </a:pPr>
-            <a:r>
-              <a:rPr sz="2200">
-                <a:solidFill>
-                  <a:srgbClr val="0A0A0A"/>
-                </a:solidFill>
-              </a:rPr>
-              <a:t>•  Setup guide + workflow runbook: a lasting reference</a:t>
-            </a:r>
-          </a:p>
-          <a:p>
-            <a:pPr>
-              <a:spcAft>
-                <a:spcPts val="1000"/>
-              </a:spcAft>
-            </a:pPr>
-            <a:r>
-              <a:rPr sz="2200">
-                <a:solidFill>
-                  <a:srgbClr val="0A0A0A"/>
-                </a:solidFill>
-              </a:rPr>
-              <a:t>•  Harbormill available for the deploy-from-source test</a:t>
-            </a:r>
-          </a:p>
-          <a:p>
-            <a:pPr>
-              <a:spcAft>
-                <a:spcPts val="1000"/>
-              </a:spcAft>
-            </a:pPr>
-            <a:r>
-              <a:rPr sz="2200">
-                <a:solidFill>
-                  <a:srgbClr val="0A0A0A"/>
-                </a:solidFill>
-              </a:rPr>
-              <a:t>•  Next: run the loop on your own first real piece of work</a:t>
+              <a:t>•  The daily loop, in five words: talk, plan, build, check, save</a:t>
+            </a:r>
+          </a:p>
+          <a:p>
+            <a:pPr>
+              <a:spcAft>
+                <a:spcPts val="1000"/>
+              </a:spcAft>
+            </a:pPr>
+            <a:r>
+              <a:rPr sz="2200">
+                <a:solidFill>
+                  <a:srgbClr val="0A0A0A"/>
+                </a:solidFill>
+              </a:rPr>
+              <a:t>•  Three commands you'll actually type — or ask Claude to</a:t>
+            </a:r>
+          </a:p>
+          <a:p>
+            <a:pPr>
+              <a:spcAft>
+                <a:spcPts val="1000"/>
+              </a:spcAft>
+            </a:pPr>
+            <a:r>
+              <a:rPr sz="2200">
+                <a:solidFill>
+                  <a:srgbClr val="0A0A0A"/>
+                </a:solidFill>
+              </a:rPr>
+              <a:t>•  Where things live: your memory folder, your skills folder</a:t>
+            </a:r>
+          </a:p>
+          <a:p>
+            <a:pPr>
+              <a:spcAft>
+                <a:spcPts val="1000"/>
+              </a:spcAft>
+            </a:pPr>
+            <a:r>
+              <a:rPr sz="2200">
+                <a:solidFill>
+                  <a:srgbClr val="0A0A0A"/>
+                </a:solidFill>
+              </a:rPr>
+              <a:t>•  When stuck, ask Claude — five questions that unstick you</a:t>
             </a:r>
           </a:p>
         </p:txBody>
@@ -10518,6 +10639,173 @@
                   <a:srgbClr val="0A0A0A"/>
                 </a:solidFill>
               </a:rPr>
+              <a:t>Where to get help / what's next</a:t>
+            </a:r>
+          </a:p>
+        </p:txBody>
+      </p:sp>
+      <p:sp>
+        <p:nvSpPr>
+          <p:cNvPr id="4" name="TextBox 3"/>
+          <p:cNvSpPr txBox="1"/>
+          <p:nvPr/>
+        </p:nvSpPr>
+        <p:spPr>
+          <a:xfrm>
+            <a:off x="822960" y="1828800"/>
+            <a:ext cx="10515600" cy="4114800"/>
+          </a:xfrm>
+          <a:prstGeom prst="rect">
+            <a:avLst/>
+          </a:prstGeom>
+          <a:noFill/>
+        </p:spPr>
+        <p:txBody>
+          <a:bodyPr wrap="square">
+            <a:spAutoFit/>
+          </a:bodyPr>
+          <a:lstStyle/>
+          <a:p>
+            <a:pPr>
+              <a:spcAft>
+                <a:spcPts val="1000"/>
+              </a:spcAft>
+            </a:pPr>
+            <a:r>
+              <a:rPr sz="2200">
+                <a:solidFill>
+                  <a:srgbClr val="0A0A0A"/>
+                </a:solidFill>
+              </a:rPr>
+              <a:t>•  Full glossary + full command cheat-sheet: always in this kit</a:t>
+            </a:r>
+          </a:p>
+          <a:p>
+            <a:pPr>
+              <a:spcAft>
+                <a:spcPts val="1000"/>
+              </a:spcAft>
+            </a:pPr>
+            <a:r>
+              <a:rPr sz="2200">
+                <a:solidFill>
+                  <a:srgbClr val="0A0A0A"/>
+                </a:solidFill>
+              </a:rPr>
+              <a:t>•  Setup guide + workflow runbook: a lasting reference</a:t>
+            </a:r>
+          </a:p>
+          <a:p>
+            <a:pPr>
+              <a:spcAft>
+                <a:spcPts val="1000"/>
+              </a:spcAft>
+            </a:pPr>
+            <a:r>
+              <a:rPr sz="2200">
+                <a:solidFill>
+                  <a:srgbClr val="0A0A0A"/>
+                </a:solidFill>
+              </a:rPr>
+              <a:t>•  Harbormill available for the deploy-from-source test</a:t>
+            </a:r>
+          </a:p>
+          <a:p>
+            <a:pPr>
+              <a:spcAft>
+                <a:spcPts val="1000"/>
+              </a:spcAft>
+            </a:pPr>
+            <a:r>
+              <a:rPr sz="2200">
+                <a:solidFill>
+                  <a:srgbClr val="0A0A0A"/>
+                </a:solidFill>
+              </a:rPr>
+              <a:t>•  Next: run the loop on your own first real piece of work</a:t>
+            </a:r>
+          </a:p>
+        </p:txBody>
+      </p:sp>
+    </p:spTree>
+  </p:cSld>
+  <p:clrMapOvr>
+    <a:masterClrMapping/>
+  </p:clrMapOvr>
+</p:sld>
+</file>
+
+<file path=ppt/slides/slide34.xml><?xml version="1.0" encoding="utf-8"?>
+<p:sld xmlns:a="http://schemas.openxmlformats.org/drawingml/2006/main" xmlns:p="http://schemas.openxmlformats.org/presentationml/2006/main" xmlns:r="http://schemas.openxmlformats.org/officeDocument/2006/relationships">
+  <p:cSld>
+    <p:bg>
+      <p:bgPr>
+        <a:solidFill>
+          <a:srgbClr val="F7F6F2"/>
+        </a:solidFill>
+        <a:effectLst/>
+      </p:bgPr>
+    </p:bg>
+    <p:spTree>
+      <p:nvGrpSpPr>
+        <p:cNvPr id="1" name=""/>
+        <p:cNvGrpSpPr/>
+        <p:nvPr/>
+      </p:nvGrpSpPr>
+      <p:grpSpPr/>
+      <p:pic>
+        <p:nvPicPr>
+          <p:cNvPr id="2" name="Picture 1" descr="harbormill-logo.png"/>
+          <p:cNvPicPr>
+            <a:picLocks noChangeAspect="1"/>
+          </p:cNvPicPr>
+          <p:nvPr/>
+        </p:nvPicPr>
+        <p:blipFill>
+          <a:blip r:embed="rId2"/>
+          <a:stretch>
+            <a:fillRect/>
+          </a:stretch>
+        </p:blipFill>
+        <p:spPr>
+          <a:xfrm>
+            <a:off x="10607040" y="365760"/>
+            <a:ext cx="548640" cy="548640"/>
+          </a:xfrm>
+          <a:prstGeom prst="rect">
+            <a:avLst/>
+          </a:prstGeom>
+        </p:spPr>
+      </p:pic>
+      <p:sp>
+        <p:nvSpPr>
+          <p:cNvPr id="3" name="TextBox 2"/>
+          <p:cNvSpPr txBox="1"/>
+          <p:nvPr/>
+        </p:nvSpPr>
+        <p:spPr>
+          <a:xfrm>
+            <a:off x="640080" y="457200"/>
+            <a:ext cx="10972800" cy="1828800"/>
+          </a:xfrm>
+          <a:prstGeom prst="rect">
+            <a:avLst/>
+          </a:prstGeom>
+          <a:noFill/>
+        </p:spPr>
+        <p:txBody>
+          <a:bodyPr wrap="square">
+            <a:spAutoFit/>
+          </a:bodyPr>
+          <a:lstStyle/>
+          <a:p>
+            <a:pPr algn="l"/>
+            <a:r>
+              <a:rPr sz="3200" b="1">
+                <a:solidFill>
+                  <a:srgbClr val="0A0A0A"/>
+                </a:solidFill>
+              </a:rPr>
               <a:t>Close</a:t>
             </a:r>
           </a:p>
@@ -10867,7 +11155,7 @@
                   <a:srgbClr val="0A0A0A"/>
                 </a:solidFill>
               </a:rPr>
-              <a:t>The ~10 terms you need</a:t>
+              <a:t>The words you'll hear (1 of 2)</a:t>
             </a:r>
           </a:p>
         </p:txBody>
@@ -10966,81 +11254,6 @@
                 </a:solidFill>
               </a:rPr>
               <a:t>•  Pull request (PR) — changes held for review</a:t>
-            </a:r>
-          </a:p>
-          <a:p>
-            <a:pPr>
-              <a:spcAft>
-                <a:spcPts val="1000"/>
-              </a:spcAft>
-            </a:pPr>
-            <a:r>
-              <a:rPr sz="2200">
-                <a:solidFill>
-                  <a:srgbClr val="0A0A0A"/>
-                </a:solidFill>
-              </a:rPr>
-              <a:t>•  Branch / worktree — a safe copy to try things in</a:t>
-            </a:r>
-          </a:p>
-          <a:p>
-            <a:pPr>
-              <a:spcAft>
-                <a:spcPts val="1000"/>
-              </a:spcAft>
-            </a:pPr>
-            <a:r>
-              <a:rPr sz="2200">
-                <a:solidFill>
-                  <a:srgbClr val="0A0A0A"/>
-                </a:solidFill>
-              </a:rPr>
-              <a:t>•  `CLAUDE.md` — the rulebook Claude reads first</a:t>
-            </a:r>
-          </a:p>
-          <a:p>
-            <a:pPr>
-              <a:spcAft>
-                <a:spcPts val="1000"/>
-              </a:spcAft>
-            </a:pPr>
-            <a:r>
-              <a:rPr sz="2200">
-                <a:solidFill>
-                  <a:srgbClr val="0A0A0A"/>
-                </a:solidFill>
-              </a:rPr>
-              <a:t>•  Memory (2nd brain) — notes across conversations</a:t>
-            </a:r>
-          </a:p>
-          <a:p>
-            <a:pPr>
-              <a:spcAft>
-                <a:spcPts val="1000"/>
-              </a:spcAft>
-            </a:pPr>
-            <a:r>
-              <a:rPr sz="2200">
-                <a:solidFill>
-                  <a:srgbClr val="0A0A0A"/>
-                </a:solidFill>
-              </a:rPr>
-              <a:t>•  Skill — a saved, reusable job recipe</a:t>
-            </a:r>
-          </a:p>
-          <a:p>
-            <a:pPr>
-              <a:spcAft>
-                <a:spcPts val="1000"/>
-              </a:spcAft>
-            </a:pPr>
-            <a:r>
-              <a:rPr sz="2200">
-                <a:solidFill>
-                  <a:srgbClr val="0A0A0A"/>
-                </a:solidFill>
-              </a:rPr>
-              <a:t>•  MCP — wired-up access to a real tool</a:t>
             </a:r>
           </a:p>
         </p:txBody>
@@ -11124,7 +11337,7 @@
                   <a:srgbClr val="0A0A0A"/>
                 </a:solidFill>
               </a:rPr>
-              <a:t>Meet: Contoso Server Health Report</a:t>
+              <a:t>The words you'll hear (2 of 2)</a:t>
             </a:r>
           </a:p>
         </p:txBody>
@@ -11162,67 +11375,67 @@
                   <a:srgbClr val="0A0A0A"/>
                 </a:solidFill>
               </a:rPr>
-              <a:t>•  A tiny fake IT tool we'll build together today</a:t>
-            </a:r>
-          </a:p>
-          <a:p>
-            <a:pPr>
-              <a:spcAft>
-                <a:spcPts val="1000"/>
-              </a:spcAft>
-            </a:pPr>
-            <a:r>
-              <a:rPr sz="2200">
-                <a:solidFill>
-                  <a:srgbClr val="0A0A0A"/>
-                </a:solidFill>
-              </a:rPr>
-              <a:t>•  Checks a list of Windows servers for low disk space</a:t>
-            </a:r>
-          </a:p>
-          <a:p>
-            <a:pPr>
-              <a:spcAft>
-                <a:spcPts val="1000"/>
-              </a:spcAft>
-            </a:pPr>
-            <a:r>
-              <a:rPr sz="2200">
-                <a:solidFill>
-                  <a:srgbClr val="0A0A0A"/>
-                </a:solidFill>
-              </a:rPr>
-              <a:t>•  Writes one simple report: OK or LOW, per server</a:t>
-            </a:r>
-          </a:p>
-          <a:p>
-            <a:pPr>
-              <a:spcAft>
-                <a:spcPts val="1000"/>
-              </a:spcAft>
-            </a:pPr>
-            <a:r>
-              <a:rPr sz="2200">
-                <a:solidFill>
-                  <a:srgbClr val="0A0A0A"/>
-                </a:solidFill>
-              </a:rPr>
-              <a:t>•  Contoso is Microsoft's own demo-company name — not a real client</a:t>
-            </a:r>
-          </a:p>
-          <a:p>
-            <a:pPr>
-              <a:spcAft>
-                <a:spcPts val="1000"/>
-              </a:spcAft>
-            </a:pPr>
-            <a:r>
-              <a:rPr sz="2200">
-                <a:solidFill>
-                  <a:srgbClr val="0A0A0A"/>
-                </a:solidFill>
-              </a:rPr>
-              <a:t>•  Every hands-on step today uses this same example</a:t>
+              <a:t>•  Branch / worktree — a safe copy to try things in</a:t>
+            </a:r>
+          </a:p>
+          <a:p>
+            <a:pPr>
+              <a:spcAft>
+                <a:spcPts val="1000"/>
+              </a:spcAft>
+            </a:pPr>
+            <a:r>
+              <a:rPr sz="2200">
+                <a:solidFill>
+                  <a:srgbClr val="0A0A0A"/>
+                </a:solidFill>
+              </a:rPr>
+              <a:t>•  `CLAUDE.md` — the rulebook Claude reads first</a:t>
+            </a:r>
+          </a:p>
+          <a:p>
+            <a:pPr>
+              <a:spcAft>
+                <a:spcPts val="1000"/>
+              </a:spcAft>
+            </a:pPr>
+            <a:r>
+              <a:rPr sz="2200">
+                <a:solidFill>
+                  <a:srgbClr val="0A0A0A"/>
+                </a:solidFill>
+              </a:rPr>
+              <a:t>•  Memory (2nd brain) — notes across conversations</a:t>
+            </a:r>
+          </a:p>
+          <a:p>
+            <a:pPr>
+              <a:spcAft>
+                <a:spcPts val="1000"/>
+              </a:spcAft>
+            </a:pPr>
+            <a:r>
+              <a:rPr sz="2200">
+                <a:solidFill>
+                  <a:srgbClr val="0A0A0A"/>
+                </a:solidFill>
+              </a:rPr>
+              <a:t>•  Skill — a saved, reusable job recipe</a:t>
+            </a:r>
+          </a:p>
+          <a:p>
+            <a:pPr>
+              <a:spcAft>
+                <a:spcPts val="1000"/>
+              </a:spcAft>
+            </a:pPr>
+            <a:r>
+              <a:rPr sz="2200">
+                <a:solidFill>
+                  <a:srgbClr val="0A0A0A"/>
+                </a:solidFill>
+              </a:rPr>
+              <a:t>•  MCP — wired-up access to a real tool</a:t>
             </a:r>
           </a:p>
         </p:txBody>
@@ -11269,8 +11482,8 @@
         </p:blipFill>
         <p:spPr>
           <a:xfrm>
-            <a:off x="548640" y="457200"/>
-            <a:ext cx="731520" cy="731520"/>
+            <a:off x="10607040" y="365760"/>
+            <a:ext cx="548640" cy="548640"/>
           </a:xfrm>
           <a:prstGeom prst="rect">
             <a:avLst/>
@@ -11285,7 +11498,7 @@
         </p:nvSpPr>
         <p:spPr>
           <a:xfrm>
-            <a:off x="640080" y="2926080"/>
+            <a:off x="640080" y="457200"/>
             <a:ext cx="10972800" cy="1828800"/>
           </a:xfrm>
           <a:prstGeom prst="rect">
@@ -11299,14 +11512,112 @@
           </a:bodyPr>
           <a:lstStyle/>
           <a:p>
-            <a:pPr algn="ctr"/>
-            <a:r>
-              <a:rPr sz="4000" b="1">
-                <a:solidFill>
-                  <a:srgbClr val="0A0A0A"/>
-                </a:solidFill>
-              </a:rPr>
-              <a:t>Session 1: Set It Up</a:t>
+            <a:pPr algn="l"/>
+            <a:r>
+              <a:rPr sz="3200" b="1">
+                <a:solidFill>
+                  <a:srgbClr val="0A0A0A"/>
+                </a:solidFill>
+              </a:rPr>
+              <a:t>Meet: Contoso Server Health Report</a:t>
+            </a:r>
+          </a:p>
+        </p:txBody>
+      </p:sp>
+      <p:sp>
+        <p:nvSpPr>
+          <p:cNvPr id="4" name="TextBox 3"/>
+          <p:cNvSpPr txBox="1"/>
+          <p:nvPr/>
+        </p:nvSpPr>
+        <p:spPr>
+          <a:xfrm>
+            <a:off x="822960" y="1828800"/>
+            <a:ext cx="10515600" cy="4114800"/>
+          </a:xfrm>
+          <a:prstGeom prst="rect">
+            <a:avLst/>
+          </a:prstGeom>
+          <a:noFill/>
+        </p:spPr>
+        <p:txBody>
+          <a:bodyPr wrap="square">
+            <a:spAutoFit/>
+          </a:bodyPr>
+          <a:lstStyle/>
+          <a:p>
+            <a:pPr>
+              <a:spcAft>
+                <a:spcPts val="1000"/>
+              </a:spcAft>
+            </a:pPr>
+            <a:r>
+              <a:rPr sz="2200">
+                <a:solidFill>
+                  <a:srgbClr val="0A0A0A"/>
+                </a:solidFill>
+              </a:rPr>
+              <a:t>•  A tiny fake IT tool we'll build together today</a:t>
+            </a:r>
+          </a:p>
+          <a:p>
+            <a:pPr>
+              <a:spcAft>
+                <a:spcPts val="1000"/>
+              </a:spcAft>
+            </a:pPr>
+            <a:r>
+              <a:rPr sz="2200">
+                <a:solidFill>
+                  <a:srgbClr val="0A0A0A"/>
+                </a:solidFill>
+              </a:rPr>
+              <a:t>•  Checks a list of Windows servers for low disk space</a:t>
+            </a:r>
+          </a:p>
+          <a:p>
+            <a:pPr>
+              <a:spcAft>
+                <a:spcPts val="1000"/>
+              </a:spcAft>
+            </a:pPr>
+            <a:r>
+              <a:rPr sz="2200">
+                <a:solidFill>
+                  <a:srgbClr val="0A0A0A"/>
+                </a:solidFill>
+              </a:rPr>
+              <a:t>•  Writes one simple report: OK or LOW, per server</a:t>
+            </a:r>
+          </a:p>
+          <a:p>
+            <a:pPr>
+              <a:spcAft>
+                <a:spcPts val="1000"/>
+              </a:spcAft>
+            </a:pPr>
+            <a:r>
+              <a:rPr sz="2200">
+                <a:solidFill>
+                  <a:srgbClr val="0A0A0A"/>
+                </a:solidFill>
+              </a:rPr>
+              <a:t>•  Contoso is Microsoft's own demo-company name — not a real client</a:t>
+            </a:r>
+          </a:p>
+          <a:p>
+            <a:pPr>
+              <a:spcAft>
+                <a:spcPts val="1000"/>
+              </a:spcAft>
+            </a:pPr>
+            <a:r>
+              <a:rPr sz="2200">
+                <a:solidFill>
+                  <a:srgbClr val="0A0A0A"/>
+                </a:solidFill>
+              </a:rPr>
+              <a:t>•  Every hands-on step today uses this same example</a:t>
             </a:r>
           </a:p>
         </p:txBody>
@@ -11353,8 +11664,8 @@
         </p:blipFill>
         <p:spPr>
           <a:xfrm>
-            <a:off x="10607040" y="365760"/>
-            <a:ext cx="548640" cy="548640"/>
+            <a:off x="548640" y="457200"/>
+            <a:ext cx="731520" cy="731520"/>
           </a:xfrm>
           <a:prstGeom prst="rect">
             <a:avLst/>
@@ -11369,7 +11680,7 @@
         </p:nvSpPr>
         <p:spPr>
           <a:xfrm>
-            <a:off x="640080" y="457200"/>
+            <a:off x="640080" y="2926080"/>
             <a:ext cx="10972800" cy="1828800"/>
           </a:xfrm>
           <a:prstGeom prst="rect">
@@ -11383,112 +11694,14 @@
           </a:bodyPr>
           <a:lstStyle/>
           <a:p>
-            <a:pPr algn="l"/>
-            <a:r>
-              <a:rPr sz="3200" b="1">
-                <a:solidFill>
-                  <a:srgbClr val="0A0A0A"/>
-                </a:solidFill>
-              </a:rPr>
-              <a:t>Get the tools on your machine</a:t>
-            </a:r>
-          </a:p>
-        </p:txBody>
-      </p:sp>
-      <p:sp>
-        <p:nvSpPr>
-          <p:cNvPr id="4" name="TextBox 3"/>
-          <p:cNvSpPr txBox="1"/>
-          <p:nvPr/>
-        </p:nvSpPr>
-        <p:spPr>
-          <a:xfrm>
-            <a:off x="822960" y="1828800"/>
-            <a:ext cx="10515600" cy="4114800"/>
-          </a:xfrm>
-          <a:prstGeom prst="rect">
-            <a:avLst/>
-          </a:prstGeom>
-          <a:noFill/>
-        </p:spPr>
-        <p:txBody>
-          <a:bodyPr wrap="square">
-            <a:spAutoFit/>
-          </a:bodyPr>
-          <a:lstStyle/>
-          <a:p>
-            <a:pPr>
-              <a:spcAft>
-                <a:spcPts val="1000"/>
-              </a:spcAft>
-            </a:pPr>
-            <a:r>
-              <a:rPr sz="2200">
-                <a:solidFill>
-                  <a:srgbClr val="0A0A0A"/>
-                </a:solidFill>
-              </a:rPr>
-              <a:t>•  Install Claude Code — one command in PowerShell</a:t>
-            </a:r>
-          </a:p>
-          <a:p>
-            <a:pPr>
-              <a:spcAft>
-                <a:spcPts val="1000"/>
-              </a:spcAft>
-            </a:pPr>
-            <a:r>
-              <a:rPr sz="2200">
-                <a:solidFill>
-                  <a:srgbClr val="0A0A0A"/>
-                </a:solidFill>
-              </a:rPr>
-              <a:t>•  Sign in with your Enterprise account</a:t>
-            </a:r>
-          </a:p>
-          <a:p>
-            <a:pPr>
-              <a:spcAft>
-                <a:spcPts val="1000"/>
-              </a:spcAft>
-            </a:pPr>
-            <a:r>
-              <a:rPr sz="2200">
-                <a:solidFill>
-                  <a:srgbClr val="0A0A0A"/>
-                </a:solidFill>
-              </a:rPr>
-              <a:t>•  Add the VS Code extension</a:t>
-            </a:r>
-          </a:p>
-          <a:p>
-            <a:pPr>
-              <a:spcAft>
-                <a:spcPts val="1000"/>
-              </a:spcAft>
-            </a:pPr>
-            <a:r>
-              <a:rPr sz="2200">
-                <a:solidFill>
-                  <a:srgbClr val="0A0A0A"/>
-                </a:solidFill>
-              </a:rPr>
-              <a:t>•  Open a terminal — just a window where you type and read replies</a:t>
-            </a:r>
-          </a:p>
-          <a:p>
-            <a:pPr>
-              <a:spcAft>
-                <a:spcPts val="1000"/>
-              </a:spcAft>
-            </a:pPr>
-            <a:r>
-              <a:rPr sz="2200">
-                <a:solidFill>
-                  <a:srgbClr val="0A0A0A"/>
-                </a:solidFill>
-              </a:rPr>
-              <a:t>•  Say hello to Claude, get a reply back</a:t>
+            <a:pPr algn="ctr"/>
+            <a:r>
+              <a:rPr sz="4000" b="1">
+                <a:solidFill>
+                  <a:srgbClr val="0A0A0A"/>
+                </a:solidFill>
+              </a:rPr>
+              <a:t>Session 1: Set It Up</a:t>
             </a:r>
           </a:p>
         </p:txBody>
@@ -11572,7 +11785,7 @@
                   <a:srgbClr val="0A0A0A"/>
                 </a:solidFill>
               </a:rPr>
-              <a:t>Checkpoint: say hello</a:t>
+              <a:t>Get the tools on your machine</a:t>
             </a:r>
           </a:p>
         </p:txBody>
@@ -11610,37 +11823,67 @@
                   <a:srgbClr val="0A0A0A"/>
                 </a:solidFill>
               </a:rPr>
-              <a:t>•  Typed "Hello" to Claude in a terminal</a:t>
-            </a:r>
-          </a:p>
-          <a:p>
-            <a:pPr>
-              <a:spcAft>
-                <a:spcPts val="1000"/>
-              </a:spcAft>
-            </a:pPr>
-            <a:r>
-              <a:rPr sz="2200">
-                <a:solidFill>
-                  <a:srgbClr val="0A0A0A"/>
-                </a:solidFill>
-              </a:rPr>
-              <a:t>•  Got a plain-English reply back</a:t>
-            </a:r>
-          </a:p>
-          <a:p>
-            <a:pPr>
-              <a:spcAft>
-                <a:spcPts val="1000"/>
-              </a:spcAft>
-            </a:pPr>
-            <a:r>
-              <a:rPr sz="2200">
-                <a:solidFill>
-                  <a:srgbClr val="0A0A0A"/>
-                </a:solidFill>
-              </a:rPr>
-              <a:t>•  That's the whole loop working end to end</a:t>
+              <a:t>•  Install Claude Code — one command in PowerShell</a:t>
+            </a:r>
+          </a:p>
+          <a:p>
+            <a:pPr>
+              <a:spcAft>
+                <a:spcPts val="1000"/>
+              </a:spcAft>
+            </a:pPr>
+            <a:r>
+              <a:rPr sz="2200">
+                <a:solidFill>
+                  <a:srgbClr val="0A0A0A"/>
+                </a:solidFill>
+              </a:rPr>
+              <a:t>•  Sign in with your Enterprise account</a:t>
+            </a:r>
+          </a:p>
+          <a:p>
+            <a:pPr>
+              <a:spcAft>
+                <a:spcPts val="1000"/>
+              </a:spcAft>
+            </a:pPr>
+            <a:r>
+              <a:rPr sz="2200">
+                <a:solidFill>
+                  <a:srgbClr val="0A0A0A"/>
+                </a:solidFill>
+              </a:rPr>
+              <a:t>•  Add the VS Code extension</a:t>
+            </a:r>
+          </a:p>
+          <a:p>
+            <a:pPr>
+              <a:spcAft>
+                <a:spcPts val="1000"/>
+              </a:spcAft>
+            </a:pPr>
+            <a:r>
+              <a:rPr sz="2200">
+                <a:solidFill>
+                  <a:srgbClr val="0A0A0A"/>
+                </a:solidFill>
+              </a:rPr>
+              <a:t>•  Open a terminal — just a window where you type and read replies</a:t>
+            </a:r>
+          </a:p>
+          <a:p>
+            <a:pPr>
+              <a:spcAft>
+                <a:spcPts val="1000"/>
+              </a:spcAft>
+            </a:pPr>
+            <a:r>
+              <a:rPr sz="2200">
+                <a:solidFill>
+                  <a:srgbClr val="0A0A0A"/>
+                </a:solidFill>
+              </a:rPr>
+              <a:t>•  Say hello to Claude, get a reply back</a:t>
             </a:r>
           </a:p>
         </p:txBody>

</xml_diff>

<commit_message>
docs(enablement): final-review fixes — README+facilitator completeness, deck wording, dead-code cleanup
</commit_message>
<xml_diff>
--- a/docs/gtm/enablement/deck/Directing-Claude.pptx
+++ b/docs/gtm/enablement/deck/Directing-Claude.pptx
@@ -7649,7 +7649,7 @@
                   <a:srgbClr val="0A0A0A"/>
                 </a:solidFill>
               </a:rPr>
-              <a:t>•  Talk it out → get a plan → build it → check it → save it</a:t>
+              <a:t>•  Talk it out → get a plan → let Claude build it → check it → save it</a:t>
             </a:r>
           </a:p>
           <a:p>
@@ -7694,7 +7694,7 @@
                   <a:srgbClr val="0A0A0A"/>
                 </a:solidFill>
               </a:rPr>
-              <a:t>•  Build it: only once you've approved the plan</a:t>
+              <a:t>•  Let Claude build it: only once you've approved the plan</a:t>
             </a:r>
           </a:p>
           <a:p>

</xml_diff>